<commit_message>
Update title slide in templates
Update the projects involved
</commit_message>
<xml_diff>
--- a/design.pptx
+++ b/design.pptx
@@ -1671,57 +1671,55 @@
       </p:pic>
       <p:pic>
         <p:nvPicPr>
-          <p:cNvPr id="10" name="Picture 4">
+          <p:cNvPr id="8" name="Picture 7">
             <a:extLst>
               <a:ext uri="{FF2B5EF4-FFF2-40B4-BE49-F238E27FC236}">
-                <a16:creationId xmlns:a16="http://schemas.microsoft.com/office/drawing/2014/main" id="{87D2793C-01C6-B180-3495-5A2067445539}"/>
+                <a16:creationId xmlns:a16="http://schemas.microsoft.com/office/drawing/2014/main" id="{74B4BBC9-1119-9703-C1C0-7A18791767C0}"/>
               </a:ext>
             </a:extLst>
           </p:cNvPr>
           <p:cNvPicPr>
-            <a:picLocks noChangeAspect="1" noChangeArrowheads="1"/>
+            <a:picLocks noChangeAspect="1"/>
           </p:cNvPicPr>
           <p:nvPr userDrawn="1"/>
         </p:nvPicPr>
         <p:blipFill>
           <a:blip r:embed="rId4" cstate="print">
             <a:extLst>
+              <a:ext uri="{BEBA8EAE-BF5A-486C-A8C5-ECC9F3942E4B}">
+                <a14:imgProps xmlns:a14="http://schemas.microsoft.com/office/drawing/2010/main">
+                  <a14:imgLayer r:embed="rId5">
+                    <a14:imgEffect>
+                      <a14:brightnessContrast bright="100000"/>
+                    </a14:imgEffect>
+                  </a14:imgLayer>
+                </a14:imgProps>
+              </a:ext>
               <a:ext uri="{28A0092B-C50C-407E-A947-70E740481C1C}">
                 <a14:useLocalDpi xmlns:a14="http://schemas.microsoft.com/office/drawing/2010/main" val="0"/>
               </a:ext>
             </a:extLst>
           </a:blip>
-          <a:srcRect/>
           <a:stretch>
             <a:fillRect/>
           </a:stretch>
         </p:blipFill>
-        <p:spPr bwMode="auto">
+        <p:spPr>
           <a:xfrm>
-            <a:off x="492630" y="3341111"/>
-            <a:ext cx="1005840" cy="233840"/>
+            <a:off x="9536165" y="6321694"/>
+            <a:ext cx="2409477" cy="401008"/>
           </a:xfrm>
           <a:prstGeom prst="rect">
             <a:avLst/>
           </a:prstGeom>
-          <a:noFill/>
-          <a:extLst>
-            <a:ext uri="{909E8E84-426E-40DD-AFC4-6F175D3DCCD1}">
-              <a14:hiddenFill xmlns:a14="http://schemas.microsoft.com/office/drawing/2010/main">
-                <a:solidFill>
-                  <a:srgbClr val="FFFFFF"/>
-                </a:solidFill>
-              </a14:hiddenFill>
-            </a:ext>
-          </a:extLst>
         </p:spPr>
       </p:pic>
       <p:sp>
         <p:nvSpPr>
-          <p:cNvPr id="19" name="TextBox 18">
+          <p:cNvPr id="5" name="TextBox 4">
             <a:extLst>
               <a:ext uri="{FF2B5EF4-FFF2-40B4-BE49-F238E27FC236}">
-                <a16:creationId xmlns:a16="http://schemas.microsoft.com/office/drawing/2014/main" id="{23984D22-2BE9-C684-93D1-920B201DC418}"/>
+                <a16:creationId xmlns:a16="http://schemas.microsoft.com/office/drawing/2014/main" id="{70DE7CB6-F30F-C5CF-E25E-4391CCD5730D}"/>
               </a:ext>
             </a:extLst>
           </p:cNvPr>
@@ -1730,7 +1728,7 @@
         </p:nvSpPr>
         <p:spPr>
           <a:xfrm>
-            <a:off x="901538" y="1776974"/>
+            <a:off x="901538" y="1454246"/>
             <a:ext cx="1144159" cy="350865"/>
           </a:xfrm>
           <a:prstGeom prst="rect">
@@ -1758,10 +1756,10 @@
       </p:sp>
       <p:sp>
         <p:nvSpPr>
-          <p:cNvPr id="24" name="TextBox 23">
+          <p:cNvPr id="7" name="TextBox 6">
             <a:extLst>
               <a:ext uri="{FF2B5EF4-FFF2-40B4-BE49-F238E27FC236}">
-                <a16:creationId xmlns:a16="http://schemas.microsoft.com/office/drawing/2014/main" id="{9EA65A86-1694-D0BE-3C46-045E2B00D094}"/>
+                <a16:creationId xmlns:a16="http://schemas.microsoft.com/office/drawing/2014/main" id="{CC09E9D5-5216-A587-FA6B-B65A405C06B8}"/>
               </a:ext>
             </a:extLst>
           </p:cNvPr>
@@ -1770,8 +1768,8 @@
         </p:nvSpPr>
         <p:spPr>
           <a:xfrm>
-            <a:off x="110789" y="2295151"/>
-            <a:ext cx="2889921" cy="932563"/>
+            <a:off x="948025" y="2646131"/>
+            <a:ext cx="1051185" cy="350865"/>
           </a:xfrm>
           <a:prstGeom prst="rect">
             <a:avLst/>
@@ -1779,7 +1777,7 @@
           <a:noFill/>
         </p:spPr>
         <p:txBody>
-          <a:bodyPr wrap="square" lIns="118872" tIns="91440" rIns="118872" bIns="91440" rtlCol="0" anchor="ctr" anchorCtr="0">
+          <a:bodyPr wrap="none" lIns="118872" tIns="91440" rIns="118872" bIns="91440" rtlCol="0" anchor="ctr" anchorCtr="0">
             <a:spAutoFit/>
           </a:bodyPr>
           <a:lstStyle/>
@@ -1790,35 +1788,18 @@
               </a:lnSpc>
             </a:pPr>
             <a:r>
-              <a:rPr lang="en-US" b="1" dirty="0"/>
-              <a:t>CASS - </a:t>
-            </a:r>
-            <a:r>
-              <a:rPr lang="en-US" b="1" i="0" u="none" strike="noStrike" kern="1200" dirty="0">
-                <a:solidFill>
-                  <a:schemeClr val="tx1"/>
-                </a:solidFill>
-                <a:effectLst/>
-                <a:latin typeface="Arial" charset="0"/>
-                <a:ea typeface="+mn-ea"/>
-                <a:cs typeface="Arial" charset="0"/>
-                <a:hlinkClick r:id="rId5"/>
-              </a:rPr>
-              <a:t>Consortium for the Advancement of Scientific Software</a:t>
-            </a:r>
-            <a:r>
-              <a:rPr lang="en-US" b="1" dirty="0"/>
-              <a:t> </a:t>
+              <a:rPr lang="en-US" sz="1200" i="1" dirty="0"/>
+              <a:t>Members of</a:t>
             </a:r>
           </a:p>
         </p:txBody>
       </p:sp>
       <p:sp>
         <p:nvSpPr>
-          <p:cNvPr id="26" name="TextBox 25">
+          <p:cNvPr id="12" name="TextBox 11">
             <a:extLst>
               <a:ext uri="{FF2B5EF4-FFF2-40B4-BE49-F238E27FC236}">
-                <a16:creationId xmlns:a16="http://schemas.microsoft.com/office/drawing/2014/main" id="{64D46951-9F99-A303-D249-27B751A562DB}"/>
+                <a16:creationId xmlns:a16="http://schemas.microsoft.com/office/drawing/2014/main" id="{E2AEC599-063B-72D6-2F66-83A252291F05}"/>
               </a:ext>
             </a:extLst>
           </p:cNvPr>
@@ -1827,7 +1808,7 @@
         </p:nvSpPr>
         <p:spPr>
           <a:xfrm>
-            <a:off x="572120" y="4562849"/>
+            <a:off x="572120" y="4624321"/>
             <a:ext cx="1802994" cy="350865"/>
           </a:xfrm>
           <a:prstGeom prst="rect">
@@ -1855,10 +1836,10 @@
       </p:sp>
       <p:grpSp>
         <p:nvGrpSpPr>
-          <p:cNvPr id="27" name="Group 26">
+          <p:cNvPr id="15" name="Group 14">
             <a:extLst>
               <a:ext uri="{FF2B5EF4-FFF2-40B4-BE49-F238E27FC236}">
-                <a16:creationId xmlns:a16="http://schemas.microsoft.com/office/drawing/2014/main" id="{CC665AB1-818C-15F6-A435-7A7C14109262}"/>
+                <a16:creationId xmlns:a16="http://schemas.microsoft.com/office/drawing/2014/main" id="{90A37BF6-6462-FB3C-25B7-EBAED4084920}"/>
               </a:ext>
             </a:extLst>
           </p:cNvPr>
@@ -1875,10 +1856,10 @@
         </p:grpSpPr>
         <p:pic>
           <p:nvPicPr>
-            <p:cNvPr id="28" name="Picture 27">
+            <p:cNvPr id="16" name="Picture 15">
               <a:extLst>
                 <a:ext uri="{FF2B5EF4-FFF2-40B4-BE49-F238E27FC236}">
-                  <a16:creationId xmlns:a16="http://schemas.microsoft.com/office/drawing/2014/main" id="{D8D4DA06-93FC-7C79-22C0-69CD6E71946F}"/>
+                  <a16:creationId xmlns:a16="http://schemas.microsoft.com/office/drawing/2014/main" id="{3CF6C489-330D-1278-20B1-372463970242}"/>
                 </a:ext>
               </a:extLst>
             </p:cNvPr>
@@ -1911,10 +1892,10 @@
         </p:pic>
         <p:pic>
           <p:nvPicPr>
-            <p:cNvPr id="29" name="Picture 28" descr="A picture containing shape&#10;&#10;Description automatically generated">
+            <p:cNvPr id="17" name="Picture 16" descr="A picture containing shape&#10;&#10;Description automatically generated">
               <a:extLst>
                 <a:ext uri="{FF2B5EF4-FFF2-40B4-BE49-F238E27FC236}">
-                  <a16:creationId xmlns:a16="http://schemas.microsoft.com/office/drawing/2014/main" id="{3A576A20-C17C-D6D5-507F-A7C5D2EE03B7}"/>
+                  <a16:creationId xmlns:a16="http://schemas.microsoft.com/office/drawing/2014/main" id="{F40C9257-5EAE-C91D-373B-1E76599701D5}"/>
                 </a:ext>
               </a:extLst>
             </p:cNvPr>
@@ -1946,12 +1927,263 @@
           </p:spPr>
         </p:pic>
       </p:grpSp>
+      <p:grpSp>
+        <p:nvGrpSpPr>
+          <p:cNvPr id="18" name="Group 17">
+            <a:extLst>
+              <a:ext uri="{FF2B5EF4-FFF2-40B4-BE49-F238E27FC236}">
+                <a16:creationId xmlns:a16="http://schemas.microsoft.com/office/drawing/2014/main" id="{CC6A95BF-1A0C-F1C7-F23F-706A76F87CA6}"/>
+              </a:ext>
+            </a:extLst>
+          </p:cNvPr>
+          <p:cNvGrpSpPr/>
+          <p:nvPr userDrawn="1"/>
+        </p:nvGrpSpPr>
+        <p:grpSpPr>
+          <a:xfrm>
+            <a:off x="-69503" y="1892144"/>
+            <a:ext cx="2985270" cy="790169"/>
+            <a:chOff x="-69503" y="2214872"/>
+            <a:chExt cx="2985270" cy="790169"/>
+          </a:xfrm>
+        </p:grpSpPr>
+        <p:pic>
+          <p:nvPicPr>
+            <p:cNvPr id="25" name="Picture 4">
+              <a:extLst>
+                <a:ext uri="{FF2B5EF4-FFF2-40B4-BE49-F238E27FC236}">
+                  <a16:creationId xmlns:a16="http://schemas.microsoft.com/office/drawing/2014/main" id="{25B0F52F-61EC-E67A-BEE5-AE883521C737}"/>
+                </a:ext>
+              </a:extLst>
+            </p:cNvPr>
+            <p:cNvPicPr>
+              <a:picLocks noChangeAspect="1" noChangeArrowheads="1"/>
+            </p:cNvPicPr>
+            <p:nvPr userDrawn="1"/>
+          </p:nvPicPr>
+          <p:blipFill>
+            <a:blip r:embed="rId8" cstate="print">
+              <a:extLst>
+                <a:ext uri="{28A0092B-C50C-407E-A947-70E740481C1C}">
+                  <a14:useLocalDpi xmlns:a14="http://schemas.microsoft.com/office/drawing/2010/main" val="0"/>
+                </a:ext>
+              </a:extLst>
+            </a:blip>
+            <a:srcRect/>
+            <a:stretch>
+              <a:fillRect/>
+            </a:stretch>
+          </p:blipFill>
+          <p:spPr bwMode="auto">
+            <a:xfrm>
+              <a:off x="1484438" y="2317122"/>
+              <a:ext cx="1371600" cy="318873"/>
+            </a:xfrm>
+            <a:prstGeom prst="rect">
+              <a:avLst/>
+            </a:prstGeom>
+            <a:noFill/>
+            <a:extLst>
+              <a:ext uri="{909E8E84-426E-40DD-AFC4-6F175D3DCCD1}">
+                <a14:hiddenFill xmlns:a14="http://schemas.microsoft.com/office/drawing/2010/main">
+                  <a:solidFill>
+                    <a:srgbClr val="FFFFFF"/>
+                  </a:solidFill>
+                </a14:hiddenFill>
+              </a:ext>
+            </a:extLst>
+          </p:spPr>
+        </p:pic>
+        <p:pic>
+          <p:nvPicPr>
+            <p:cNvPr id="30" name="Picture 2" descr="A picture containing graphics, logo, font, symbol&#10;&#10;Description automatically generated">
+              <a:extLst>
+                <a:ext uri="{FF2B5EF4-FFF2-40B4-BE49-F238E27FC236}">
+                  <a16:creationId xmlns:a16="http://schemas.microsoft.com/office/drawing/2014/main" id="{A9BB0698-1E6E-118B-C4E9-35B9D67F5DB9}"/>
+                </a:ext>
+              </a:extLst>
+            </p:cNvPr>
+            <p:cNvPicPr>
+              <a:picLocks noChangeAspect="1" noChangeArrowheads="1"/>
+            </p:cNvPicPr>
+            <p:nvPr userDrawn="1"/>
+          </p:nvPicPr>
+          <p:blipFill>
+            <a:blip r:embed="rId9" cstate="print">
+              <a:extLst>
+                <a:ext uri="{28A0092B-C50C-407E-A947-70E740481C1C}">
+                  <a14:useLocalDpi xmlns:a14="http://schemas.microsoft.com/office/drawing/2010/main" val="0"/>
+                </a:ext>
+              </a:extLst>
+            </a:blip>
+            <a:srcRect/>
+            <a:stretch>
+              <a:fillRect/>
+            </a:stretch>
+          </p:blipFill>
+          <p:spPr bwMode="auto">
+            <a:xfrm>
+              <a:off x="321595" y="2214872"/>
+              <a:ext cx="841248" cy="523372"/>
+            </a:xfrm>
+            <a:prstGeom prst="rect">
+              <a:avLst/>
+            </a:prstGeom>
+            <a:noFill/>
+            <a:extLst>
+              <a:ext uri="{909E8E84-426E-40DD-AFC4-6F175D3DCCD1}">
+                <a14:hiddenFill xmlns:a14="http://schemas.microsoft.com/office/drawing/2010/main">
+                  <a:solidFill>
+                    <a:srgbClr val="FFFFFF"/>
+                  </a:solidFill>
+                </a14:hiddenFill>
+              </a:ext>
+            </a:extLst>
+          </p:spPr>
+        </p:pic>
+        <p:sp>
+          <p:nvSpPr>
+            <p:cNvPr id="31" name="TextBox 30">
+              <a:extLst>
+                <a:ext uri="{FF2B5EF4-FFF2-40B4-BE49-F238E27FC236}">
+                  <a16:creationId xmlns:a16="http://schemas.microsoft.com/office/drawing/2014/main" id="{D9F57AC4-079D-30A9-F299-0EAF3ECA2772}"/>
+                </a:ext>
+              </a:extLst>
+            </p:cNvPr>
+            <p:cNvSpPr txBox="1"/>
+            <p:nvPr userDrawn="1"/>
+          </p:nvSpPr>
+          <p:spPr>
+            <a:xfrm>
+              <a:off x="-69503" y="2668026"/>
+              <a:ext cx="1631472" cy="337015"/>
+            </a:xfrm>
+            <a:prstGeom prst="rect">
+              <a:avLst/>
+            </a:prstGeom>
+            <a:noFill/>
+          </p:spPr>
+          <p:txBody>
+            <a:bodyPr wrap="none" lIns="118872" tIns="91440" rIns="118872" bIns="91440" rtlCol="0" anchor="ctr" anchorCtr="0">
+              <a:spAutoFit/>
+            </a:bodyPr>
+            <a:lstStyle/>
+            <a:p>
+              <a:pPr algn="l">
+                <a:lnSpc>
+                  <a:spcPct val="90000"/>
+                </a:lnSpc>
+              </a:pPr>
+              <a:r>
+                <a:rPr lang="en-US" sz="1050" i="1" dirty="0">
+                  <a:hlinkClick r:id="rId10"/>
+                </a:rPr>
+                <a:t>https://pesoproject.org</a:t>
+              </a:r>
+              <a:endParaRPr lang="en-US" sz="1050" i="1" dirty="0"/>
+            </a:p>
+          </p:txBody>
+        </p:sp>
+        <p:sp>
+          <p:nvSpPr>
+            <p:cNvPr id="32" name="TextBox 31">
+              <a:extLst>
+                <a:ext uri="{FF2B5EF4-FFF2-40B4-BE49-F238E27FC236}">
+                  <a16:creationId xmlns:a16="http://schemas.microsoft.com/office/drawing/2014/main" id="{CA5C2C8A-9502-60F5-68E1-3296B30C2880}"/>
+                </a:ext>
+              </a:extLst>
+            </p:cNvPr>
+            <p:cNvSpPr txBox="1"/>
+            <p:nvPr userDrawn="1"/>
+          </p:nvSpPr>
+          <p:spPr>
+            <a:xfrm>
+              <a:off x="1423755" y="2668026"/>
+              <a:ext cx="1492012" cy="337015"/>
+            </a:xfrm>
+            <a:prstGeom prst="rect">
+              <a:avLst/>
+            </a:prstGeom>
+            <a:noFill/>
+          </p:spPr>
+          <p:txBody>
+            <a:bodyPr wrap="none" lIns="118872" tIns="91440" rIns="118872" bIns="91440" rtlCol="0" anchor="ctr" anchorCtr="0">
+              <a:spAutoFit/>
+            </a:bodyPr>
+            <a:lstStyle/>
+            <a:p>
+              <a:pPr algn="l">
+                <a:lnSpc>
+                  <a:spcPct val="90000"/>
+                </a:lnSpc>
+              </a:pPr>
+              <a:r>
+                <a:rPr lang="en-US" sz="1050" i="1" dirty="0">
+                  <a:hlinkClick r:id="rId11"/>
+                </a:rPr>
+                <a:t>https://rapids.lbl.gov</a:t>
+              </a:r>
+              <a:endParaRPr lang="en-US" sz="1050" i="1" dirty="0"/>
+            </a:p>
+          </p:txBody>
+        </p:sp>
+      </p:grpSp>
+      <p:sp>
+        <p:nvSpPr>
+          <p:cNvPr id="33" name="TextBox 32">
+            <a:extLst>
+              <a:ext uri="{FF2B5EF4-FFF2-40B4-BE49-F238E27FC236}">
+                <a16:creationId xmlns:a16="http://schemas.microsoft.com/office/drawing/2014/main" id="{A7BFAE79-6B18-E222-E24F-73C71226E876}"/>
+              </a:ext>
+            </a:extLst>
+          </p:cNvPr>
+          <p:cNvSpPr txBox="1"/>
+          <p:nvPr userDrawn="1"/>
+        </p:nvSpPr>
+        <p:spPr>
+          <a:xfrm>
+            <a:off x="166031" y="4011401"/>
+            <a:ext cx="2605511" cy="655564"/>
+          </a:xfrm>
+          <a:prstGeom prst="rect">
+            <a:avLst/>
+          </a:prstGeom>
+          <a:noFill/>
+        </p:spPr>
+        <p:txBody>
+          <a:bodyPr wrap="square" lIns="118872" tIns="91440" rIns="118872" bIns="91440" rtlCol="0" anchor="ctr" anchorCtr="0">
+            <a:spAutoFit/>
+          </a:bodyPr>
+          <a:lstStyle/>
+          <a:p>
+            <a:pPr algn="ctr">
+              <a:lnSpc>
+                <a:spcPct val="90000"/>
+              </a:lnSpc>
+            </a:pPr>
+            <a:r>
+              <a:rPr lang="en-US" sz="1200" i="1" dirty="0"/>
+              <a:t>Consortium for the Advancement of Scientific Software</a:t>
+            </a:r>
+            <a:br>
+              <a:rPr lang="en-US" sz="1200" i="1" dirty="0"/>
+            </a:br>
+            <a:r>
+              <a:rPr lang="en-US" sz="1000" i="1" dirty="0">
+                <a:hlinkClick r:id="rId12"/>
+              </a:rPr>
+              <a:t>https://cass.community</a:t>
+            </a:r>
+            <a:endParaRPr lang="en-US" sz="1200" i="1" dirty="0"/>
+          </a:p>
+        </p:txBody>
+      </p:sp>
       <p:pic>
         <p:nvPicPr>
-          <p:cNvPr id="8" name="Picture 7">
+          <p:cNvPr id="34" name="Picture 33" descr="A picture containing arrow&#10;&#10;AI-generated content may be incorrect.">
             <a:extLst>
               <a:ext uri="{FF2B5EF4-FFF2-40B4-BE49-F238E27FC236}">
-                <a16:creationId xmlns:a16="http://schemas.microsoft.com/office/drawing/2014/main" id="{74B4BBC9-1119-9703-C1C0-7A18791767C0}"/>
+                <a16:creationId xmlns:a16="http://schemas.microsoft.com/office/drawing/2014/main" id="{D88D7312-C802-BE51-9FA0-6A6B23F22C0B}"/>
               </a:ext>
             </a:extLst>
           </p:cNvPr>
@@ -1961,17 +2193,8 @@
           <p:nvPr userDrawn="1"/>
         </p:nvPicPr>
         <p:blipFill>
-          <a:blip r:embed="rId8" cstate="print">
+          <a:blip r:embed="rId13" cstate="print">
             <a:extLst>
-              <a:ext uri="{BEBA8EAE-BF5A-486C-A8C5-ECC9F3942E4B}">
-                <a14:imgProps xmlns:a14="http://schemas.microsoft.com/office/drawing/2010/main">
-                  <a14:imgLayer r:embed="rId9">
-                    <a14:imgEffect>
-                      <a14:brightnessContrast bright="100000"/>
-                    </a14:imgEffect>
-                  </a14:imgLayer>
-                </a14:imgProps>
-              </a:ext>
               <a:ext uri="{28A0092B-C50C-407E-A947-70E740481C1C}">
                 <a14:useLocalDpi xmlns:a14="http://schemas.microsoft.com/office/drawing/2010/main" val="0"/>
               </a:ext>
@@ -1983,8 +2206,8 @@
         </p:blipFill>
         <p:spPr>
           <a:xfrm>
-            <a:off x="9536165" y="6321694"/>
-            <a:ext cx="2409477" cy="401008"/>
+            <a:off x="849769" y="2974535"/>
+            <a:ext cx="1238034" cy="1128739"/>
           </a:xfrm>
           <a:prstGeom prst="rect">
             <a:avLst/>
@@ -2707,163 +2930,12 @@
           </a:prstGeom>
         </p:spPr>
       </p:pic>
-      <p:grpSp>
-        <p:nvGrpSpPr>
-          <p:cNvPr id="21" name="Group 20">
+      <p:sp>
+        <p:nvSpPr>
+          <p:cNvPr id="12" name="TextBox 11">
             <a:extLst>
               <a:ext uri="{FF2B5EF4-FFF2-40B4-BE49-F238E27FC236}">
-                <a16:creationId xmlns:a16="http://schemas.microsoft.com/office/drawing/2014/main" id="{23F39736-1AFA-8528-C9E3-41B55EABEDCA}"/>
-              </a:ext>
-            </a:extLst>
-          </p:cNvPr>
-          <p:cNvGrpSpPr/>
-          <p:nvPr userDrawn="1"/>
-        </p:nvGrpSpPr>
-        <p:grpSpPr>
-          <a:xfrm>
-            <a:off x="366259" y="3655396"/>
-            <a:ext cx="2214716" cy="356329"/>
-            <a:chOff x="341278" y="3628835"/>
-            <a:chExt cx="2214716" cy="356329"/>
-          </a:xfrm>
-        </p:grpSpPr>
-        <p:pic>
-          <p:nvPicPr>
-            <p:cNvPr id="6" name="Picture 2">
-              <a:extLst>
-                <a:ext uri="{FF2B5EF4-FFF2-40B4-BE49-F238E27FC236}">
-                  <a16:creationId xmlns:a16="http://schemas.microsoft.com/office/drawing/2014/main" id="{EF0692E1-7D85-78AD-9CB9-EDC5C0A1CD96}"/>
-                </a:ext>
-              </a:extLst>
-            </p:cNvPr>
-            <p:cNvPicPr>
-              <a:picLocks noChangeAspect="1" noChangeArrowheads="1"/>
-            </p:cNvPicPr>
-            <p:nvPr userDrawn="1"/>
-          </p:nvPicPr>
-          <p:blipFill>
-            <a:blip r:embed="rId6">
-              <a:extLst>
-                <a:ext uri="{28A0092B-C50C-407E-A947-70E740481C1C}">
-                  <a14:useLocalDpi xmlns:a14="http://schemas.microsoft.com/office/drawing/2010/main" val="0"/>
-                </a:ext>
-              </a:extLst>
-            </a:blip>
-            <a:srcRect/>
-            <a:stretch>
-              <a:fillRect/>
-            </a:stretch>
-          </p:blipFill>
-          <p:spPr bwMode="auto">
-            <a:xfrm>
-              <a:off x="341278" y="3628835"/>
-              <a:ext cx="1005840" cy="356329"/>
-            </a:xfrm>
-            <a:prstGeom prst="rect">
-              <a:avLst/>
-            </a:prstGeom>
-            <a:noFill/>
-            <a:extLst>
-              <a:ext uri="{909E8E84-426E-40DD-AFC4-6F175D3DCCD1}">
-                <a14:hiddenFill xmlns:a14="http://schemas.microsoft.com/office/drawing/2010/main">
-                  <a:solidFill>
-                    <a:srgbClr val="FFFFFF"/>
-                  </a:solidFill>
-                </a14:hiddenFill>
-              </a:ext>
-            </a:extLst>
-          </p:spPr>
-        </p:pic>
-        <p:pic>
-          <p:nvPicPr>
-            <p:cNvPr id="7" name="Picture 4">
-              <a:extLst>
-                <a:ext uri="{FF2B5EF4-FFF2-40B4-BE49-F238E27FC236}">
-                  <a16:creationId xmlns:a16="http://schemas.microsoft.com/office/drawing/2014/main" id="{05CDAB3D-B8D6-9AC9-8507-6F95230AEE45}"/>
-                </a:ext>
-              </a:extLst>
-            </p:cNvPr>
-            <p:cNvPicPr>
-              <a:picLocks noChangeAspect="1" noChangeArrowheads="1"/>
-            </p:cNvPicPr>
-            <p:nvPr userDrawn="1"/>
-          </p:nvPicPr>
-          <p:blipFill>
-            <a:blip r:embed="rId7" cstate="print">
-              <a:extLst>
-                <a:ext uri="{28A0092B-C50C-407E-A947-70E740481C1C}">
-                  <a14:useLocalDpi xmlns:a14="http://schemas.microsoft.com/office/drawing/2010/main" val="0"/>
-                </a:ext>
-              </a:extLst>
-            </a:blip>
-            <a:srcRect/>
-            <a:stretch>
-              <a:fillRect/>
-            </a:stretch>
-          </p:blipFill>
-          <p:spPr bwMode="auto">
-            <a:xfrm>
-              <a:off x="1550154" y="3690079"/>
-              <a:ext cx="1005840" cy="233840"/>
-            </a:xfrm>
-            <a:prstGeom prst="rect">
-              <a:avLst/>
-            </a:prstGeom>
-            <a:noFill/>
-            <a:extLst>
-              <a:ext uri="{909E8E84-426E-40DD-AFC4-6F175D3DCCD1}">
-                <a14:hiddenFill xmlns:a14="http://schemas.microsoft.com/office/drawing/2010/main">
-                  <a:solidFill>
-                    <a:srgbClr val="FFFFFF"/>
-                  </a:solidFill>
-                </a14:hiddenFill>
-              </a:ext>
-            </a:extLst>
-          </p:spPr>
-        </p:pic>
-      </p:grpSp>
-      <p:pic>
-        <p:nvPicPr>
-          <p:cNvPr id="11" name="Picture 10" descr="A black and white sign with blue text&#10;&#10;Description automatically generated">
-            <a:extLst>
-              <a:ext uri="{FF2B5EF4-FFF2-40B4-BE49-F238E27FC236}">
-                <a16:creationId xmlns:a16="http://schemas.microsoft.com/office/drawing/2014/main" id="{A50B83FE-88FB-1C61-17CC-A58C0BE092BF}"/>
-              </a:ext>
-            </a:extLst>
-          </p:cNvPr>
-          <p:cNvPicPr>
-            <a:picLocks noChangeAspect="1"/>
-          </p:cNvPicPr>
-          <p:nvPr userDrawn="1"/>
-        </p:nvPicPr>
-        <p:blipFill>
-          <a:blip r:embed="rId8" cstate="print">
-            <a:extLst>
-              <a:ext uri="{28A0092B-C50C-407E-A947-70E740481C1C}">
-                <a14:useLocalDpi xmlns:a14="http://schemas.microsoft.com/office/drawing/2010/main" val="0"/>
-              </a:ext>
-            </a:extLst>
-          </a:blip>
-          <a:stretch>
-            <a:fillRect/>
-          </a:stretch>
-        </p:blipFill>
-        <p:spPr>
-          <a:xfrm>
-            <a:off x="970697" y="4125123"/>
-            <a:ext cx="1005840" cy="324328"/>
-          </a:xfrm>
-          <a:prstGeom prst="rect">
-            <a:avLst/>
-          </a:prstGeom>
-        </p:spPr>
-      </p:pic>
-      <p:sp>
-        <p:nvSpPr>
-          <p:cNvPr id="8" name="TextBox 7">
-            <a:extLst>
-              <a:ext uri="{FF2B5EF4-FFF2-40B4-BE49-F238E27FC236}">
-                <a16:creationId xmlns:a16="http://schemas.microsoft.com/office/drawing/2014/main" id="{DBDB4EA8-7E00-EB97-386F-806F04EDC41A}"/>
+                <a16:creationId xmlns:a16="http://schemas.microsoft.com/office/drawing/2014/main" id="{1BC79204-B1FE-B3CE-9EA4-08178150AF2C}"/>
               </a:ext>
             </a:extLst>
           </p:cNvPr>
@@ -2872,7 +2944,7 @@
         </p:nvSpPr>
         <p:spPr>
           <a:xfrm>
-            <a:off x="901538" y="1776974"/>
+            <a:off x="901538" y="1454246"/>
             <a:ext cx="1144159" cy="350865"/>
           </a:xfrm>
           <a:prstGeom prst="rect">
@@ -2900,10 +2972,10 @@
       </p:sp>
       <p:sp>
         <p:nvSpPr>
-          <p:cNvPr id="9" name="TextBox 8">
+          <p:cNvPr id="19" name="TextBox 18">
             <a:extLst>
               <a:ext uri="{FF2B5EF4-FFF2-40B4-BE49-F238E27FC236}">
-                <a16:creationId xmlns:a16="http://schemas.microsoft.com/office/drawing/2014/main" id="{9C6AA8F1-3D17-46A7-8926-BC4892D4C51C}"/>
+                <a16:creationId xmlns:a16="http://schemas.microsoft.com/office/drawing/2014/main" id="{540AE08A-1688-EA24-31E1-990C11A652D2}"/>
               </a:ext>
             </a:extLst>
           </p:cNvPr>
@@ -2912,48 +2984,8 @@
         </p:nvSpPr>
         <p:spPr>
           <a:xfrm>
-            <a:off x="28657" y="2079048"/>
-            <a:ext cx="2889921" cy="932563"/>
-          </a:xfrm>
-          <a:prstGeom prst="rect">
-            <a:avLst/>
-          </a:prstGeom>
-          <a:noFill/>
-        </p:spPr>
-        <p:txBody>
-          <a:bodyPr wrap="square" lIns="118872" tIns="91440" rIns="118872" bIns="91440" rtlCol="0" anchor="ctr" anchorCtr="0">
-            <a:spAutoFit/>
-          </a:bodyPr>
-          <a:lstStyle/>
-          <a:p>
-            <a:pPr algn="l">
-              <a:lnSpc>
-                <a:spcPct val="90000"/>
-              </a:lnSpc>
-            </a:pPr>
-            <a:r>
-              <a:rPr lang="en-US" b="1" dirty="0"/>
-              <a:t>COLABS: Collaboration for Better Software for Science</a:t>
-            </a:r>
-          </a:p>
-        </p:txBody>
-      </p:sp>
-      <p:sp>
-        <p:nvSpPr>
-          <p:cNvPr id="10" name="TextBox 9">
-            <a:extLst>
-              <a:ext uri="{FF2B5EF4-FFF2-40B4-BE49-F238E27FC236}">
-                <a16:creationId xmlns:a16="http://schemas.microsoft.com/office/drawing/2014/main" id="{CE38D39D-3F53-1EF5-8F58-4DF913CFD07D}"/>
-              </a:ext>
-            </a:extLst>
-          </p:cNvPr>
-          <p:cNvSpPr txBox="1"/>
-          <p:nvPr userDrawn="1"/>
-        </p:nvSpPr>
-        <p:spPr>
-          <a:xfrm>
-            <a:off x="676315" y="3191133"/>
-            <a:ext cx="1594604" cy="350865"/>
+            <a:off x="948025" y="2646131"/>
+            <a:ext cx="1051185" cy="350865"/>
           </a:xfrm>
           <a:prstGeom prst="rect">
             <a:avLst/>
@@ -2973,17 +3005,17 @@
             </a:pPr>
             <a:r>
               <a:rPr lang="en-US" sz="1200" i="1" dirty="0"/>
-              <a:t>In collaboration with</a:t>
+              <a:t>Members of</a:t>
             </a:r>
           </a:p>
         </p:txBody>
       </p:sp>
       <p:sp>
         <p:nvSpPr>
-          <p:cNvPr id="15" name="TextBox 14">
+          <p:cNvPr id="23" name="TextBox 22">
             <a:extLst>
               <a:ext uri="{FF2B5EF4-FFF2-40B4-BE49-F238E27FC236}">
-                <a16:creationId xmlns:a16="http://schemas.microsoft.com/office/drawing/2014/main" id="{38A567DA-27A0-BFAF-CB9E-0EA56E125664}"/>
+                <a16:creationId xmlns:a16="http://schemas.microsoft.com/office/drawing/2014/main" id="{817DDBF2-5B08-51D6-AF32-A3234C4A1BFA}"/>
               </a:ext>
             </a:extLst>
           </p:cNvPr>
@@ -2992,7 +3024,7 @@
         </p:nvSpPr>
         <p:spPr>
           <a:xfrm>
-            <a:off x="572120" y="4562849"/>
+            <a:off x="572120" y="4624321"/>
             <a:ext cx="1802994" cy="350865"/>
           </a:xfrm>
           <a:prstGeom prst="rect">
@@ -3020,10 +3052,10 @@
       </p:sp>
       <p:grpSp>
         <p:nvGrpSpPr>
-          <p:cNvPr id="20" name="Group 19">
+          <p:cNvPr id="24" name="Group 23">
             <a:extLst>
               <a:ext uri="{FF2B5EF4-FFF2-40B4-BE49-F238E27FC236}">
-                <a16:creationId xmlns:a16="http://schemas.microsoft.com/office/drawing/2014/main" id="{63A83523-6C92-DDA5-E072-BAC75B3276B6}"/>
+                <a16:creationId xmlns:a16="http://schemas.microsoft.com/office/drawing/2014/main" id="{6B00848E-3F23-BA04-676F-CE00B7BEAD31}"/>
               </a:ext>
             </a:extLst>
           </p:cNvPr>
@@ -3040,10 +3072,10 @@
         </p:grpSpPr>
         <p:pic>
           <p:nvPicPr>
-            <p:cNvPr id="17" name="Picture 16">
+            <p:cNvPr id="25" name="Picture 24">
               <a:extLst>
                 <a:ext uri="{FF2B5EF4-FFF2-40B4-BE49-F238E27FC236}">
-                  <a16:creationId xmlns:a16="http://schemas.microsoft.com/office/drawing/2014/main" id="{70EB972A-C812-2D11-E993-9648F06DCD53}"/>
+                  <a16:creationId xmlns:a16="http://schemas.microsoft.com/office/drawing/2014/main" id="{C6373EB4-0467-E2CD-A904-29721BF6E12A}"/>
                 </a:ext>
               </a:extLst>
             </p:cNvPr>
@@ -3053,7 +3085,7 @@
             <p:nvPr userDrawn="1"/>
           </p:nvPicPr>
           <p:blipFill>
-            <a:blip r:embed="rId9" cstate="print">
+            <a:blip r:embed="rId6" cstate="print">
               <a:extLst>
                 <a:ext uri="{28A0092B-C50C-407E-A947-70E740481C1C}">
                   <a14:useLocalDpi xmlns:a14="http://schemas.microsoft.com/office/drawing/2010/main" val="0"/>
@@ -3076,10 +3108,10 @@
         </p:pic>
         <p:pic>
           <p:nvPicPr>
-            <p:cNvPr id="18" name="Picture 17" descr="A picture containing shape&#10;&#10;Description automatically generated">
+            <p:cNvPr id="26" name="Picture 25" descr="A picture containing shape&#10;&#10;Description automatically generated">
               <a:extLst>
                 <a:ext uri="{FF2B5EF4-FFF2-40B4-BE49-F238E27FC236}">
-                  <a16:creationId xmlns:a16="http://schemas.microsoft.com/office/drawing/2014/main" id="{DC5CC62A-5FBA-A239-536C-E231ED3105F0}"/>
+                  <a16:creationId xmlns:a16="http://schemas.microsoft.com/office/drawing/2014/main" id="{74E24885-3320-7DE6-F3F3-EF61A8477440}"/>
                 </a:ext>
               </a:extLst>
             </p:cNvPr>
@@ -3089,7 +3121,7 @@
             <p:nvPr userDrawn="1"/>
           </p:nvPicPr>
           <p:blipFill>
-            <a:blip r:embed="rId10">
+            <a:blip r:embed="rId7">
               <a:extLst>
                 <a:ext uri="{28A0092B-C50C-407E-A947-70E740481C1C}">
                   <a14:useLocalDpi xmlns:a14="http://schemas.microsoft.com/office/drawing/2010/main" val="0"/>
@@ -3111,6 +3143,293 @@
           </p:spPr>
         </p:pic>
       </p:grpSp>
+      <p:grpSp>
+        <p:nvGrpSpPr>
+          <p:cNvPr id="27" name="Group 26">
+            <a:extLst>
+              <a:ext uri="{FF2B5EF4-FFF2-40B4-BE49-F238E27FC236}">
+                <a16:creationId xmlns:a16="http://schemas.microsoft.com/office/drawing/2014/main" id="{578CBBCD-B85F-C77F-73CC-29DBBBEFD434}"/>
+              </a:ext>
+            </a:extLst>
+          </p:cNvPr>
+          <p:cNvGrpSpPr/>
+          <p:nvPr userDrawn="1"/>
+        </p:nvGrpSpPr>
+        <p:grpSpPr>
+          <a:xfrm>
+            <a:off x="-69503" y="1892144"/>
+            <a:ext cx="2985270" cy="790169"/>
+            <a:chOff x="-69503" y="2214872"/>
+            <a:chExt cx="2985270" cy="790169"/>
+          </a:xfrm>
+        </p:grpSpPr>
+        <p:pic>
+          <p:nvPicPr>
+            <p:cNvPr id="28" name="Picture 4">
+              <a:extLst>
+                <a:ext uri="{FF2B5EF4-FFF2-40B4-BE49-F238E27FC236}">
+                  <a16:creationId xmlns:a16="http://schemas.microsoft.com/office/drawing/2014/main" id="{A695C840-7733-06CC-6313-CDA74D8B9956}"/>
+                </a:ext>
+              </a:extLst>
+            </p:cNvPr>
+            <p:cNvPicPr>
+              <a:picLocks noChangeAspect="1" noChangeArrowheads="1"/>
+            </p:cNvPicPr>
+            <p:nvPr userDrawn="1"/>
+          </p:nvPicPr>
+          <p:blipFill>
+            <a:blip r:embed="rId8" cstate="print">
+              <a:extLst>
+                <a:ext uri="{28A0092B-C50C-407E-A947-70E740481C1C}">
+                  <a14:useLocalDpi xmlns:a14="http://schemas.microsoft.com/office/drawing/2010/main" val="0"/>
+                </a:ext>
+              </a:extLst>
+            </a:blip>
+            <a:srcRect/>
+            <a:stretch>
+              <a:fillRect/>
+            </a:stretch>
+          </p:blipFill>
+          <p:spPr bwMode="auto">
+            <a:xfrm>
+              <a:off x="1484438" y="2317122"/>
+              <a:ext cx="1371600" cy="318873"/>
+            </a:xfrm>
+            <a:prstGeom prst="rect">
+              <a:avLst/>
+            </a:prstGeom>
+            <a:noFill/>
+            <a:extLst>
+              <a:ext uri="{909E8E84-426E-40DD-AFC4-6F175D3DCCD1}">
+                <a14:hiddenFill xmlns:a14="http://schemas.microsoft.com/office/drawing/2010/main">
+                  <a:solidFill>
+                    <a:srgbClr val="FFFFFF"/>
+                  </a:solidFill>
+                </a14:hiddenFill>
+              </a:ext>
+            </a:extLst>
+          </p:spPr>
+        </p:pic>
+        <p:pic>
+          <p:nvPicPr>
+            <p:cNvPr id="29" name="Picture 2" descr="A picture containing graphics, logo, font, symbol&#10;&#10;Description automatically generated">
+              <a:extLst>
+                <a:ext uri="{FF2B5EF4-FFF2-40B4-BE49-F238E27FC236}">
+                  <a16:creationId xmlns:a16="http://schemas.microsoft.com/office/drawing/2014/main" id="{E9A196A8-BB8A-3FB8-7BB2-5D16AEE27D5D}"/>
+                </a:ext>
+              </a:extLst>
+            </p:cNvPr>
+            <p:cNvPicPr>
+              <a:picLocks noChangeAspect="1" noChangeArrowheads="1"/>
+            </p:cNvPicPr>
+            <p:nvPr userDrawn="1"/>
+          </p:nvPicPr>
+          <p:blipFill>
+            <a:blip r:embed="rId9" cstate="print">
+              <a:extLst>
+                <a:ext uri="{28A0092B-C50C-407E-A947-70E740481C1C}">
+                  <a14:useLocalDpi xmlns:a14="http://schemas.microsoft.com/office/drawing/2010/main" val="0"/>
+                </a:ext>
+              </a:extLst>
+            </a:blip>
+            <a:srcRect/>
+            <a:stretch>
+              <a:fillRect/>
+            </a:stretch>
+          </p:blipFill>
+          <p:spPr bwMode="auto">
+            <a:xfrm>
+              <a:off x="321595" y="2214872"/>
+              <a:ext cx="841248" cy="523372"/>
+            </a:xfrm>
+            <a:prstGeom prst="rect">
+              <a:avLst/>
+            </a:prstGeom>
+            <a:noFill/>
+            <a:extLst>
+              <a:ext uri="{909E8E84-426E-40DD-AFC4-6F175D3DCCD1}">
+                <a14:hiddenFill xmlns:a14="http://schemas.microsoft.com/office/drawing/2010/main">
+                  <a:solidFill>
+                    <a:srgbClr val="FFFFFF"/>
+                  </a:solidFill>
+                </a14:hiddenFill>
+              </a:ext>
+            </a:extLst>
+          </p:spPr>
+        </p:pic>
+        <p:sp>
+          <p:nvSpPr>
+            <p:cNvPr id="30" name="TextBox 29">
+              <a:extLst>
+                <a:ext uri="{FF2B5EF4-FFF2-40B4-BE49-F238E27FC236}">
+                  <a16:creationId xmlns:a16="http://schemas.microsoft.com/office/drawing/2014/main" id="{615945D9-6363-9514-7C4E-6E75FC9D15C7}"/>
+                </a:ext>
+              </a:extLst>
+            </p:cNvPr>
+            <p:cNvSpPr txBox="1"/>
+            <p:nvPr userDrawn="1"/>
+          </p:nvSpPr>
+          <p:spPr>
+            <a:xfrm>
+              <a:off x="-69503" y="2668026"/>
+              <a:ext cx="1631472" cy="337015"/>
+            </a:xfrm>
+            <a:prstGeom prst="rect">
+              <a:avLst/>
+            </a:prstGeom>
+            <a:noFill/>
+          </p:spPr>
+          <p:txBody>
+            <a:bodyPr wrap="none" lIns="118872" tIns="91440" rIns="118872" bIns="91440" rtlCol="0" anchor="ctr" anchorCtr="0">
+              <a:spAutoFit/>
+            </a:bodyPr>
+            <a:lstStyle/>
+            <a:p>
+              <a:pPr algn="l">
+                <a:lnSpc>
+                  <a:spcPct val="90000"/>
+                </a:lnSpc>
+              </a:pPr>
+              <a:r>
+                <a:rPr lang="en-US" sz="1050" i="1" dirty="0">
+                  <a:hlinkClick r:id="rId10"/>
+                </a:rPr>
+                <a:t>https://pesoproject.org</a:t>
+              </a:r>
+              <a:endParaRPr lang="en-US" sz="1050" i="1" dirty="0"/>
+            </a:p>
+          </p:txBody>
+        </p:sp>
+        <p:sp>
+          <p:nvSpPr>
+            <p:cNvPr id="31" name="TextBox 30">
+              <a:extLst>
+                <a:ext uri="{FF2B5EF4-FFF2-40B4-BE49-F238E27FC236}">
+                  <a16:creationId xmlns:a16="http://schemas.microsoft.com/office/drawing/2014/main" id="{2956306F-B98B-1D3E-A678-C01A178BDF63}"/>
+                </a:ext>
+              </a:extLst>
+            </p:cNvPr>
+            <p:cNvSpPr txBox="1"/>
+            <p:nvPr userDrawn="1"/>
+          </p:nvSpPr>
+          <p:spPr>
+            <a:xfrm>
+              <a:off x="1423755" y="2668026"/>
+              <a:ext cx="1492012" cy="337015"/>
+            </a:xfrm>
+            <a:prstGeom prst="rect">
+              <a:avLst/>
+            </a:prstGeom>
+            <a:noFill/>
+          </p:spPr>
+          <p:txBody>
+            <a:bodyPr wrap="none" lIns="118872" tIns="91440" rIns="118872" bIns="91440" rtlCol="0" anchor="ctr" anchorCtr="0">
+              <a:spAutoFit/>
+            </a:bodyPr>
+            <a:lstStyle/>
+            <a:p>
+              <a:pPr algn="l">
+                <a:lnSpc>
+                  <a:spcPct val="90000"/>
+                </a:lnSpc>
+              </a:pPr>
+              <a:r>
+                <a:rPr lang="en-US" sz="1050" i="1" dirty="0">
+                  <a:hlinkClick r:id="rId11"/>
+                </a:rPr>
+                <a:t>https://rapids.lbl.gov</a:t>
+              </a:r>
+              <a:endParaRPr lang="en-US" sz="1050" i="1" dirty="0"/>
+            </a:p>
+          </p:txBody>
+        </p:sp>
+      </p:grpSp>
+      <p:sp>
+        <p:nvSpPr>
+          <p:cNvPr id="32" name="TextBox 31">
+            <a:extLst>
+              <a:ext uri="{FF2B5EF4-FFF2-40B4-BE49-F238E27FC236}">
+                <a16:creationId xmlns:a16="http://schemas.microsoft.com/office/drawing/2014/main" id="{EC239939-96E2-AD74-8BAE-BA514F5CF767}"/>
+              </a:ext>
+            </a:extLst>
+          </p:cNvPr>
+          <p:cNvSpPr txBox="1"/>
+          <p:nvPr userDrawn="1"/>
+        </p:nvSpPr>
+        <p:spPr>
+          <a:xfrm>
+            <a:off x="166031" y="4011401"/>
+            <a:ext cx="2605511" cy="655564"/>
+          </a:xfrm>
+          <a:prstGeom prst="rect">
+            <a:avLst/>
+          </a:prstGeom>
+          <a:noFill/>
+        </p:spPr>
+        <p:txBody>
+          <a:bodyPr wrap="square" lIns="118872" tIns="91440" rIns="118872" bIns="91440" rtlCol="0" anchor="ctr" anchorCtr="0">
+            <a:spAutoFit/>
+          </a:bodyPr>
+          <a:lstStyle/>
+          <a:p>
+            <a:pPr algn="ctr">
+              <a:lnSpc>
+                <a:spcPct val="90000"/>
+              </a:lnSpc>
+            </a:pPr>
+            <a:r>
+              <a:rPr lang="en-US" sz="1200" i="1" dirty="0"/>
+              <a:t>Consortium for the Advancement of Scientific Software</a:t>
+            </a:r>
+            <a:br>
+              <a:rPr lang="en-US" sz="1200" i="1" dirty="0"/>
+            </a:br>
+            <a:r>
+              <a:rPr lang="en-US" sz="1000" i="1" dirty="0">
+                <a:hlinkClick r:id="rId12"/>
+              </a:rPr>
+              <a:t>https://cass.community</a:t>
+            </a:r>
+            <a:endParaRPr lang="en-US" sz="1200" i="1" dirty="0"/>
+          </a:p>
+        </p:txBody>
+      </p:sp>
+      <p:pic>
+        <p:nvPicPr>
+          <p:cNvPr id="33" name="Picture 32" descr="A picture containing arrow&#10;&#10;AI-generated content may be incorrect.">
+            <a:extLst>
+              <a:ext uri="{FF2B5EF4-FFF2-40B4-BE49-F238E27FC236}">
+                <a16:creationId xmlns:a16="http://schemas.microsoft.com/office/drawing/2014/main" id="{80DDFE6A-0805-7B54-8CF2-129C05C534B0}"/>
+              </a:ext>
+            </a:extLst>
+          </p:cNvPr>
+          <p:cNvPicPr>
+            <a:picLocks noChangeAspect="1"/>
+          </p:cNvPicPr>
+          <p:nvPr userDrawn="1"/>
+        </p:nvPicPr>
+        <p:blipFill>
+          <a:blip r:embed="rId13" cstate="print">
+            <a:extLst>
+              <a:ext uri="{28A0092B-C50C-407E-A947-70E740481C1C}">
+                <a14:useLocalDpi xmlns:a14="http://schemas.microsoft.com/office/drawing/2010/main" val="0"/>
+              </a:ext>
+            </a:extLst>
+          </a:blip>
+          <a:stretch>
+            <a:fillRect/>
+          </a:stretch>
+        </p:blipFill>
+        <p:spPr>
+          <a:xfrm>
+            <a:off x="849769" y="2974535"/>
+            <a:ext cx="1238034" cy="1128739"/>
+          </a:xfrm>
+          <a:prstGeom prst="rect">
+            <a:avLst/>
+          </a:prstGeom>
+        </p:spPr>
+      </p:pic>
     </p:spTree>
     <p:extLst>
       <p:ext uri="{BB962C8B-B14F-4D97-AF65-F5344CB8AC3E}">
@@ -9668,7 +9987,7 @@
           <a:noFill/>
           <a:extLst>
             <a:ext uri="{909E8E84-426E-40dd-AFC4-6F175D3DCCD1}">
-              <a14:hiddenFill xmlns="" xmlns:a14="http://schemas.microsoft.com/office/drawing/2010/main">
+              <a14:hiddenFill xmlns:a14="http://schemas.microsoft.com/office/drawing/2010/main" xmlns="">
                 <a:solidFill>
                   <a:srgbClr val="FFFFFF"/>
                 </a:solidFill>
@@ -33844,15 +34163,6 @@
 </file>
 
 <file path=customXml/item2.xml><?xml version="1.0" encoding="utf-8"?>
-<?mso-contentType ?>
-<FormTemplates xmlns="http://schemas.microsoft.com/sharepoint/v3/contenttype/forms">
-  <Display>DocumentLibraryForm</Display>
-  <Edit>DocumentLibraryForm</Edit>
-  <New>DocumentLibraryForm</New>
-</FormTemplates>
-</file>
-
-<file path=customXml/item3.xml><?xml version="1.0" encoding="utf-8"?>
 <ct:contentTypeSchema xmlns:ct="http://schemas.microsoft.com/office/2006/metadata/contentType" xmlns:ma="http://schemas.microsoft.com/office/2006/metadata/properties/metaAttributes" ct:_="" ma:_="" ma:contentTypeName="Document" ma:contentTypeID="0x010100565464437F680748A68B85EB6594EA7D" ma:contentTypeVersion="0" ma:contentTypeDescription="Create a new document." ma:contentTypeScope="" ma:versionID="fe3f4dd58d5914c51cfc6deaa8ad845c">
   <xsd:schema xmlns:xsd="http://www.w3.org/2001/XMLSchema" xmlns:p="http://schemas.microsoft.com/office/2006/metadata/properties" targetNamespace="http://schemas.microsoft.com/office/2006/metadata/properties" ma:root="true" ma:fieldsID="4aeb20c0e3442673af7ee10786458764">
     <xsd:element name="properties">
@@ -33901,6 +34211,15 @@
 </ct:contentTypeSchema>
 </file>
 
+<file path=customXml/item3.xml><?xml version="1.0" encoding="utf-8"?>
+<?mso-contentType ?>
+<FormTemplates xmlns="http://schemas.microsoft.com/sharepoint/v3/contenttype/forms">
+  <Display>DocumentLibraryForm</Display>
+  <Edit>DocumentLibraryForm</Edit>
+  <New>DocumentLibraryForm</New>
+</FormTemplates>
+</file>
+
 <file path=customXml/itemProps1.xml><?xml version="1.0" encoding="utf-8"?>
 <ds:datastoreItem xmlns:ds="http://schemas.openxmlformats.org/officeDocument/2006/customXml" ds:itemID="{A50EC660-24D0-43A0-AE5E-E274115E726B}">
   <ds:schemaRefs>
@@ -33917,14 +34236,6 @@
 </file>
 
 <file path=customXml/itemProps2.xml><?xml version="1.0" encoding="utf-8"?>
-<ds:datastoreItem xmlns:ds="http://schemas.openxmlformats.org/officeDocument/2006/customXml" ds:itemID="{19E20559-B232-4371-8690-E3D8007EDB82}">
-  <ds:schemaRefs>
-    <ds:schemaRef ds:uri="http://schemas.microsoft.com/sharepoint/v3/contenttype/forms"/>
-  </ds:schemaRefs>
-</ds:datastoreItem>
-</file>
-
-<file path=customXml/itemProps3.xml><?xml version="1.0" encoding="utf-8"?>
 <ds:datastoreItem xmlns:ds="http://schemas.openxmlformats.org/officeDocument/2006/customXml" ds:itemID="{E8DB7DEB-074E-4EE8-9B6E-FD277323109C}">
   <ds:schemaRefs>
     <ds:schemaRef ds:uri="http://schemas.microsoft.com/office/2006/metadata/contentType"/>
@@ -33937,4 +34248,12 @@
     <ds:schemaRef ds:uri="http://schemas.microsoft.com/office/internal/2005/internalDocumentation"/>
   </ds:schemaRefs>
 </ds:datastoreItem>
+</file>
+
+<file path=customXml/itemProps3.xml><?xml version="1.0" encoding="utf-8"?>
+<ds:datastoreItem xmlns:ds="http://schemas.openxmlformats.org/officeDocument/2006/customXml" ds:itemID="{19E20559-B232-4371-8690-E3D8007EDB82}">
+  <ds:schemaRefs>
+    <ds:schemaRef ds:uri="http://schemas.microsoft.com/sharepoint/v3/contenttype/forms"/>
+  </ds:schemaRefs>
+</ds:datastoreItem>
 </file>
</xml_diff>

<commit_message>
Add DOIs and links to references
</commit_message>
<xml_diff>
--- a/design.pptx
+++ b/design.pptx
@@ -290,7 +290,7 @@
           <a:p>
             <a:fld id="{0B842F42-2CE9-4E35-95C1-410DC08A50B1}" type="datetimeFigureOut">
               <a:rPr lang="en-US" smtClean="0"/>
-              <a:t>8/5/2025</a:t>
+              <a:t>8/6/2025</a:t>
             </a:fld>
             <a:endParaRPr lang="en-US"/>
           </a:p>
@@ -455,7 +455,7 @@
           <a:p>
             <a:fld id="{6F282904-F315-4730-8D91-37D99E141A6F}" type="datetimeFigureOut">
               <a:rPr lang="en-US" smtClean="0"/>
-              <a:t>8/5/2025</a:t>
+              <a:t>8/6/2025</a:t>
             </a:fld>
             <a:endParaRPr lang="en-US"/>
           </a:p>
@@ -5127,7 +5127,7 @@
           <a:p>
             <a:fld id="{68F49DD1-DDB5-AB43-B311-7649AD474C82}" type="datetimeFigureOut">
               <a:rPr lang="en-US" smtClean="0"/>
-              <a:t>8/5/2025</a:t>
+              <a:t>8/6/2025</a:t>
             </a:fld>
             <a:endParaRPr lang="en-US"/>
           </a:p>
@@ -9987,7 +9987,7 @@
           <a:noFill/>
           <a:extLst>
             <a:ext uri="{909E8E84-426E-40dd-AFC4-6F175D3DCCD1}">
-              <a14:hiddenFill xmlns:a14="http://schemas.microsoft.com/office/drawing/2010/main" xmlns="">
+              <a14:hiddenFill xmlns="" xmlns:a14="http://schemas.microsoft.com/office/drawing/2010/main">
                 <a:solidFill>
                   <a:srgbClr val="FFFFFF"/>
                 </a:solidFill>
@@ -29422,8 +29422,22 @@
                   <a:srgbClr val="FFFFFF"/>
                 </a:highlight>
               </a:rPr>
-              <a:t>” Computing in Science &amp; Engineering, 2021</a:t>
-            </a:r>
+              <a:t>” Computing in Science &amp; Engineering, 2021. DOI:</a:t>
+            </a:r>
+            <a:r>
+              <a:rPr lang="en-US" u="sng" dirty="0">
+                <a:highlight>
+                  <a:srgbClr val="FFFFFF"/>
+                </a:highlight>
+                <a:hlinkClick r:id="rId3"/>
+              </a:rPr>
+              <a:t>10.1109/MCSE.2021.3069343</a:t>
+            </a:r>
+            <a:endParaRPr lang="en-US" dirty="0">
+              <a:highlight>
+                <a:srgbClr val="FFFFFF"/>
+              </a:highlight>
+            </a:endParaRPr>
           </a:p>
           <a:p>
             <a:r>
@@ -29512,8 +29526,40 @@
                 </a:highlight>
                 <a:latin typeface="Arial" panose="020B0604020202020204" pitchFamily="34" charset="0"/>
               </a:rPr>
-              <a:t> 19 (2022): 101168.</a:t>
-            </a:r>
+              <a:t> 19 (2022): 101168. </a:t>
+            </a:r>
+            <a:r>
+              <a:rPr lang="en-US" dirty="0">
+                <a:solidFill>
+                  <a:srgbClr val="222222"/>
+                </a:solidFill>
+                <a:highlight>
+                  <a:srgbClr val="FFFFFF"/>
+                </a:highlight>
+                <a:latin typeface="Arial" panose="020B0604020202020204" pitchFamily="34" charset="0"/>
+              </a:rPr>
+              <a:t>DOI:</a:t>
+            </a:r>
+            <a:r>
+              <a:rPr lang="en-US" dirty="0">
+                <a:solidFill>
+                  <a:srgbClr val="222222"/>
+                </a:solidFill>
+                <a:latin typeface="Arial" panose="020B0604020202020204" pitchFamily="34" charset="0"/>
+                <a:hlinkClick r:id="rId4"/>
+              </a:rPr>
+              <a:t>10.1016/j.softx.2022.101168</a:t>
+            </a:r>
+            <a:endParaRPr lang="en-US" b="0" i="0" u="none" strike="noStrike" dirty="0">
+              <a:solidFill>
+                <a:srgbClr val="222222"/>
+              </a:solidFill>
+              <a:effectLst/>
+              <a:highlight>
+                <a:srgbClr val="FFFFFF"/>
+              </a:highlight>
+              <a:latin typeface="Arial" panose="020B0604020202020204" pitchFamily="34" charset="0"/>
+            </a:endParaRPr>
           </a:p>
           <a:p>
             <a:r>
@@ -29573,7 +29619,32 @@
                 <a:effectLst/>
                 <a:latin typeface="Arial" panose="020B0604020202020204" pitchFamily="34" charset="0"/>
               </a:rPr>
-              <a:t> preprint arXiv:2401.03378</a:t>
+              <a:t> preprint </a:t>
+            </a:r>
+            <a:r>
+              <a:rPr lang="en-US" b="0" i="1" u="none" strike="noStrike" dirty="0">
+                <a:solidFill>
+                  <a:srgbClr val="222222"/>
+                </a:solidFill>
+                <a:effectLst/>
+                <a:latin typeface="Arial" panose="020B0604020202020204" pitchFamily="34" charset="0"/>
+                <a:hlinkClick r:id="rId5"/>
+              </a:rPr>
+              <a:t>arXiv:2401.03378</a:t>
+            </a:r>
+            <a:r>
+              <a:rPr lang="en-US" b="0" i="0" u="none" strike="noStrike" dirty="0">
+                <a:solidFill>
+                  <a:srgbClr val="222222"/>
+                </a:solidFill>
+                <a:effectLst/>
+                <a:highlight>
+                  <a:srgbClr val="FFFFFF"/>
+                </a:highlight>
+                <a:latin typeface="Arial" panose="020B0604020202020204" pitchFamily="34" charset="0"/>
+                <a:hlinkClick r:id="rId5"/>
+              </a:rPr>
+              <a:t> </a:t>
             </a:r>
             <a:r>
               <a:rPr lang="en-US" b="0" i="0" u="none" strike="noStrike" dirty="0">
@@ -29586,7 +29657,7 @@
                 </a:highlight>
                 <a:latin typeface="Arial" panose="020B0604020202020204" pitchFamily="34" charset="0"/>
               </a:rPr>
-              <a:t> (2024).</a:t>
+              <a:t>(2024).</a:t>
             </a:r>
           </a:p>
           <a:p>
@@ -29650,8 +29721,27 @@
                 </a:highlight>
                 <a:latin typeface="Arial" panose="020B0604020202020204" pitchFamily="34" charset="0"/>
               </a:rPr>
-              <a:t>. Cham: Springer International Publishing, 2021.</a:t>
-            </a:r>
+              <a:t>. Cham: Springer International Publishing, 2021. DOI:</a:t>
+            </a:r>
+            <a:r>
+              <a:rPr lang="en-US" dirty="0">
+                <a:highlight>
+                  <a:srgbClr val="FFFFFF"/>
+                </a:highlight>
+                <a:hlinkClick r:id="rId6"/>
+              </a:rPr>
+              <a:t>10.1007/978-3-031-06156-1_13</a:t>
+            </a:r>
+            <a:endParaRPr lang="en-US" b="0" i="0" u="none" strike="noStrike" dirty="0">
+              <a:solidFill>
+                <a:srgbClr val="222222"/>
+              </a:solidFill>
+              <a:effectLst/>
+              <a:highlight>
+                <a:srgbClr val="FFFFFF"/>
+              </a:highlight>
+              <a:latin typeface="Arial" panose="020B0604020202020204" pitchFamily="34" charset="0"/>
+            </a:endParaRPr>
           </a:p>
           <a:p>
             <a:r>
@@ -29740,7 +29830,29 @@
                 </a:highlight>
                 <a:latin typeface="Arial" panose="020B0604020202020204" pitchFamily="34" charset="0"/>
               </a:rPr>
-              <a:t> (2023).</a:t>
+              <a:t> (2023). </a:t>
+            </a:r>
+            <a:r>
+              <a:rPr lang="en-US" dirty="0">
+                <a:solidFill>
+                  <a:srgbClr val="222222"/>
+                </a:solidFill>
+                <a:highlight>
+                  <a:srgbClr val="FFFFFF"/>
+                </a:highlight>
+                <a:latin typeface="Arial" panose="020B0604020202020204" pitchFamily="34" charset="0"/>
+              </a:rPr>
+              <a:t>DOI:</a:t>
+            </a:r>
+            <a:r>
+              <a:rPr lang="en-US" dirty="0">
+                <a:solidFill>
+                  <a:srgbClr val="222222"/>
+                </a:solidFill>
+                <a:latin typeface="Arial" panose="020B0604020202020204" pitchFamily="34" charset="0"/>
+                <a:hlinkClick r:id="rId7"/>
+              </a:rPr>
+              <a:t>10.1016/j.future.2023.07.014</a:t>
             </a:r>
             <a:endParaRPr lang="en-US" dirty="0"/>
           </a:p>
@@ -34163,6 +34275,15 @@
 </file>
 
 <file path=customXml/item2.xml><?xml version="1.0" encoding="utf-8"?>
+<?mso-contentType ?>
+<FormTemplates xmlns="http://schemas.microsoft.com/sharepoint/v3/contenttype/forms">
+  <Display>DocumentLibraryForm</Display>
+  <Edit>DocumentLibraryForm</Edit>
+  <New>DocumentLibraryForm</New>
+</FormTemplates>
+</file>
+
+<file path=customXml/item3.xml><?xml version="1.0" encoding="utf-8"?>
 <ct:contentTypeSchema xmlns:ct="http://schemas.microsoft.com/office/2006/metadata/contentType" xmlns:ma="http://schemas.microsoft.com/office/2006/metadata/properties/metaAttributes" ct:_="" ma:_="" ma:contentTypeName="Document" ma:contentTypeID="0x010100565464437F680748A68B85EB6594EA7D" ma:contentTypeVersion="0" ma:contentTypeDescription="Create a new document." ma:contentTypeScope="" ma:versionID="fe3f4dd58d5914c51cfc6deaa8ad845c">
   <xsd:schema xmlns:xsd="http://www.w3.org/2001/XMLSchema" xmlns:p="http://schemas.microsoft.com/office/2006/metadata/properties" targetNamespace="http://schemas.microsoft.com/office/2006/metadata/properties" ma:root="true" ma:fieldsID="4aeb20c0e3442673af7ee10786458764">
     <xsd:element name="properties">
@@ -34211,15 +34332,6 @@
 </ct:contentTypeSchema>
 </file>
 
-<file path=customXml/item3.xml><?xml version="1.0" encoding="utf-8"?>
-<?mso-contentType ?>
-<FormTemplates xmlns="http://schemas.microsoft.com/sharepoint/v3/contenttype/forms">
-  <Display>DocumentLibraryForm</Display>
-  <Edit>DocumentLibraryForm</Edit>
-  <New>DocumentLibraryForm</New>
-</FormTemplates>
-</file>
-
 <file path=customXml/itemProps1.xml><?xml version="1.0" encoding="utf-8"?>
 <ds:datastoreItem xmlns:ds="http://schemas.openxmlformats.org/officeDocument/2006/customXml" ds:itemID="{A50EC660-24D0-43A0-AE5E-E274115E726B}">
   <ds:schemaRefs>
@@ -34236,6 +34348,14 @@
 </file>
 
 <file path=customXml/itemProps2.xml><?xml version="1.0" encoding="utf-8"?>
+<ds:datastoreItem xmlns:ds="http://schemas.openxmlformats.org/officeDocument/2006/customXml" ds:itemID="{19E20559-B232-4371-8690-E3D8007EDB82}">
+  <ds:schemaRefs>
+    <ds:schemaRef ds:uri="http://schemas.microsoft.com/sharepoint/v3/contenttype/forms"/>
+  </ds:schemaRefs>
+</ds:datastoreItem>
+</file>
+
+<file path=customXml/itemProps3.xml><?xml version="1.0" encoding="utf-8"?>
 <ds:datastoreItem xmlns:ds="http://schemas.openxmlformats.org/officeDocument/2006/customXml" ds:itemID="{E8DB7DEB-074E-4EE8-9B6E-FD277323109C}">
   <ds:schemaRefs>
     <ds:schemaRef ds:uri="http://schemas.microsoft.com/office/2006/metadata/contentType"/>
@@ -34248,12 +34368,4 @@
     <ds:schemaRef ds:uri="http://schemas.microsoft.com/office/internal/2005/internalDocumentation"/>
   </ds:schemaRefs>
 </ds:datastoreItem>
-</file>
-
-<file path=customXml/itemProps3.xml><?xml version="1.0" encoding="utf-8"?>
-<ds:datastoreItem xmlns:ds="http://schemas.openxmlformats.org/officeDocument/2006/customXml" ds:itemID="{19E20559-B232-4371-8690-E3D8007EDB82}">
-  <ds:schemaRefs>
-    <ds:schemaRef ds:uri="http://schemas.microsoft.com/sharepoint/v3/contenttype/forms"/>
-  </ds:schemaRefs>
-</ds:datastoreItem>
 </file>
</xml_diff>

<commit_message>
updated some modules for SCA/HPC-Asia
</commit_message>
<xml_diff>
--- a/design.pptx
+++ b/design.pptx
@@ -290,7 +290,7 @@
           <a:p>
             <a:fld id="{0B842F42-2CE9-4E35-95C1-410DC08A50B1}" type="datetimeFigureOut">
               <a:rPr lang="en-US" smtClean="0"/>
-              <a:t>8/6/2025</a:t>
+              <a:t>12/2/25</a:t>
             </a:fld>
             <a:endParaRPr lang="en-US"/>
           </a:p>
@@ -455,7 +455,7 @@
           <a:p>
             <a:fld id="{6F282904-F315-4730-8D91-37D99E141A6F}" type="datetimeFigureOut">
               <a:rPr lang="en-US" smtClean="0"/>
-              <a:t>8/6/2025</a:t>
+              <a:t>12/2/25</a:t>
             </a:fld>
             <a:endParaRPr lang="en-US"/>
           </a:p>
@@ -5127,7 +5127,7 @@
           <a:p>
             <a:fld id="{68F49DD1-DDB5-AB43-B311-7649AD474C82}" type="datetimeFigureOut">
               <a:rPr lang="en-US" smtClean="0"/>
-              <a:t>8/6/2025</a:t>
+              <a:t>12/2/25</a:t>
             </a:fld>
             <a:endParaRPr lang="en-US"/>
           </a:p>
@@ -6279,8 +6279,23 @@
                 <a:effectLst/>
                 <a:latin typeface="+mn-lt"/>
               </a:rPr>
-              <a:t>Software Sustainability track @ Argonne Training Program on Extreme-Scale Computing summer school</a:t>
-            </a:r>
+              <a:t>Better Software for Reproducible Science tutorial @ SCA/HPC-Asia 2026 Conferenc</a:t>
+            </a:r>
+            <a:r>
+              <a:rPr lang="en-US" dirty="0">
+                <a:solidFill>
+                  <a:srgbClr val="111111"/>
+                </a:solidFill>
+              </a:rPr>
+              <a:t>e, Osaka, Japan</a:t>
+            </a:r>
+            <a:endParaRPr lang="en-US" sz="2000" b="0" i="0" dirty="0">
+              <a:solidFill>
+                <a:srgbClr val="111111"/>
+              </a:solidFill>
+              <a:effectLst/>
+              <a:latin typeface="+mn-lt"/>
+            </a:endParaRPr>
           </a:p>
         </p:txBody>
       </p:sp>
@@ -9987,7 +10002,7 @@
           <a:noFill/>
           <a:extLst>
             <a:ext uri="{909E8E84-426E-40dd-AFC4-6F175D3DCCD1}">
-              <a14:hiddenFill xmlns="" xmlns:a14="http://schemas.microsoft.com/office/drawing/2010/main">
+              <a14:hiddenFill xmlns:a14="http://schemas.microsoft.com/office/drawing/2010/main" xmlns="">
                 <a:solidFill>
                   <a:srgbClr val="FFFFFF"/>
                 </a:solidFill>
@@ -15328,21 +15343,7 @@
             </a:pPr>
             <a:r>
               <a:rPr lang="en-US" sz="1600" b="1" dirty="0"/>
-              <a:t>The requested citation the overall tutorial is: </a:t>
-            </a:r>
-            <a:r>
-              <a:rPr lang="en-US" sz="1600" dirty="0"/>
-              <a:t>Anshu Dubey, David E. Bernholdt, and Todd Gamblin, Software Sustainability track, in Argonne Training Program on Extreme-Scale Computing, St. Charles, Illinois, 2025. DOI: </a:t>
-            </a:r>
-            <a:r>
-              <a:rPr lang="en-US" sz="1600" dirty="0">
-                <a:hlinkClick r:id="rId4"/>
-              </a:rPr>
-              <a:t>10.6084/m9.figshare.29816981</a:t>
-            </a:r>
-            <a:r>
-              <a:rPr lang="en-US" sz="1600" dirty="0"/>
-              <a:t>.</a:t>
+              <a:t>The requested citation the overall tutorial is:</a:t>
             </a:r>
             <a:endParaRPr lang="en-US" sz="1600" b="0" i="0" dirty="0">
               <a:solidFill>
@@ -15498,7 +15499,7 @@
           <p:nvPr/>
         </p:nvPicPr>
         <p:blipFill>
-          <a:blip r:embed="rId5">
+          <a:blip r:embed="rId4">
             <a:extLst>
               <a:ext uri="{28A0092B-C50C-407E-A947-70E740481C1C}">
                 <a14:useLocalDpi xmlns:a14="http://schemas.microsoft.com/office/drawing/2010/main" val="0"/>
@@ -34269,18 +34270,18 @@
 </file>
 
 <file path=customXml/item1.xml><?xml version="1.0" encoding="utf-8"?>
-<p:properties xmlns:p="http://schemas.microsoft.com/office/2006/metadata/properties" xmlns:xsi="http://www.w3.org/2001/XMLSchema-instance" xmlns:pc="http://schemas.microsoft.com/office/infopath/2007/PartnerControls">
-  <documentManagement/>
-</p:properties>
-</file>
-
-<file path=customXml/item2.xml><?xml version="1.0" encoding="utf-8"?>
 <?mso-contentType ?>
 <FormTemplates xmlns="http://schemas.microsoft.com/sharepoint/v3/contenttype/forms">
   <Display>DocumentLibraryForm</Display>
   <Edit>DocumentLibraryForm</Edit>
   <New>DocumentLibraryForm</New>
 </FormTemplates>
+</file>
+
+<file path=customXml/item2.xml><?xml version="1.0" encoding="utf-8"?>
+<p:properties xmlns:p="http://schemas.microsoft.com/office/2006/metadata/properties" xmlns:xsi="http://www.w3.org/2001/XMLSchema-instance" xmlns:pc="http://schemas.microsoft.com/office/infopath/2007/PartnerControls">
+  <documentManagement/>
+</p:properties>
 </file>
 
 <file path=customXml/item3.xml><?xml version="1.0" encoding="utf-8"?>
@@ -34333,6 +34334,14 @@
 </file>
 
 <file path=customXml/itemProps1.xml><?xml version="1.0" encoding="utf-8"?>
+<ds:datastoreItem xmlns:ds="http://schemas.openxmlformats.org/officeDocument/2006/customXml" ds:itemID="{19E20559-B232-4371-8690-E3D8007EDB82}">
+  <ds:schemaRefs>
+    <ds:schemaRef ds:uri="http://schemas.microsoft.com/sharepoint/v3/contenttype/forms"/>
+  </ds:schemaRefs>
+</ds:datastoreItem>
+</file>
+
+<file path=customXml/itemProps2.xml><?xml version="1.0" encoding="utf-8"?>
 <ds:datastoreItem xmlns:ds="http://schemas.openxmlformats.org/officeDocument/2006/customXml" ds:itemID="{A50EC660-24D0-43A0-AE5E-E274115E726B}">
   <ds:schemaRefs>
     <ds:schemaRef ds:uri="http://purl.org/dc/elements/1.1/"/>
@@ -34343,14 +34352,6 @@
     <ds:schemaRef ds:uri="http://www.w3.org/XML/1998/namespace"/>
     <ds:schemaRef ds:uri="http://purl.org/dc/dcmitype/"/>
     <ds:schemaRef ds:uri="http://schemas.microsoft.com/office/infopath/2007/PartnerControls"/>
-  </ds:schemaRefs>
-</ds:datastoreItem>
-</file>
-
-<file path=customXml/itemProps2.xml><?xml version="1.0" encoding="utf-8"?>
-<ds:datastoreItem xmlns:ds="http://schemas.openxmlformats.org/officeDocument/2006/customXml" ds:itemID="{19E20559-B232-4371-8690-E3D8007EDB82}">
-  <ds:schemaRefs>
-    <ds:schemaRef ds:uri="http://schemas.microsoft.com/sharepoint/v3/contenttype/forms"/>
   </ds:schemaRefs>
 </ds:datastoreItem>
 </file>

</xml_diff>

<commit_message>
License, title page, and other updates
</commit_message>
<xml_diff>
--- a/design.pptx
+++ b/design.pptx
@@ -12,7 +12,7 @@
   </p:handoutMasterIdLst>
   <p:sldIdLst>
     <p:sldId id="5601" r:id="rId5"/>
-    <p:sldId id="5685" r:id="rId6"/>
+    <p:sldId id="320" r:id="rId6"/>
     <p:sldId id="5590" r:id="rId7"/>
     <p:sldId id="5577" r:id="rId8"/>
     <p:sldId id="5591" r:id="rId9"/>
@@ -290,7 +290,7 @@
           <a:p>
             <a:fld id="{0B842F42-2CE9-4E35-95C1-410DC08A50B1}" type="datetimeFigureOut">
               <a:rPr lang="en-US" smtClean="0"/>
-              <a:t>12/2/25</a:t>
+              <a:t>1/22/2026</a:t>
             </a:fld>
             <a:endParaRPr lang="en-US"/>
           </a:p>
@@ -455,7 +455,7 @@
           <a:p>
             <a:fld id="{6F282904-F315-4730-8D91-37D99E141A6F}" type="datetimeFigureOut">
               <a:rPr lang="en-US" smtClean="0"/>
-              <a:t>12/2/25</a:t>
+              <a:t>1/22/2026</a:t>
             </a:fld>
             <a:endParaRPr lang="en-US"/>
           </a:p>
@@ -5127,7 +5127,7 @@
           <a:p>
             <a:fld id="{68F49DD1-DDB5-AB43-B311-7649AD474C82}" type="datetimeFigureOut">
               <a:rPr lang="en-US" smtClean="0"/>
-              <a:t>12/2/25</a:t>
+              <a:t>1/22/2026</a:t>
             </a:fld>
             <a:endParaRPr lang="en-US"/>
           </a:p>
@@ -6259,7 +6259,7 @@
         <p:spPr>
           <a:xfrm>
             <a:off x="3176925" y="3161813"/>
-            <a:ext cx="8292316" cy="646331"/>
+            <a:ext cx="8292316" cy="1200329"/>
           </a:xfrm>
         </p:spPr>
         <p:txBody>
@@ -6272,29 +6272,29 @@
               </a:spcBef>
             </a:pPr>
             <a:r>
-              <a:rPr lang="en-US" sz="2000" b="0" i="0" dirty="0">
-                <a:solidFill>
-                  <a:srgbClr val="111111"/>
-                </a:solidFill>
-                <a:effectLst/>
-                <a:latin typeface="+mn-lt"/>
-              </a:rPr>
-              <a:t>Better Software for Reproducible Science tutorial @ SCA/HPC-Asia 2026 Conferenc</a:t>
-            </a:r>
-            <a:r>
-              <a:rPr lang="en-US" dirty="0">
-                <a:solidFill>
-                  <a:srgbClr val="111111"/>
-                </a:solidFill>
-              </a:rPr>
-              <a:t>e, Osaka, Japan</a:t>
-            </a:r>
-            <a:endParaRPr lang="en-US" sz="2000" b="0" i="0" dirty="0">
+              <a:rPr lang="en-US" dirty="0"/>
+              <a:t>Better Software for Science with High-Performance Computing tutorial @ </a:t>
+            </a:r>
+            <a:r>
+              <a:rPr lang="en-US" dirty="0" err="1"/>
+              <a:t>SupercomputingAsia</a:t>
+            </a:r>
+            <a:r>
+              <a:rPr lang="en-US" dirty="0"/>
+              <a:t> 2026 (SCA 2026)/The International Conference on High Performance Computing in Asia-Pacific Region 2026 (</a:t>
+            </a:r>
+            <a:r>
+              <a:rPr lang="en-US" dirty="0" err="1"/>
+              <a:t>HPCAsia</a:t>
+            </a:r>
+            <a:r>
+              <a:rPr lang="en-US" dirty="0"/>
+              <a:t> 2026) conference</a:t>
+            </a:r>
+            <a:endParaRPr lang="en-US" dirty="0">
               <a:solidFill>
                 <a:srgbClr val="111111"/>
               </a:solidFill>
-              <a:effectLst/>
-              <a:latin typeface="+mn-lt"/>
             </a:endParaRPr>
           </a:p>
         </p:txBody>
@@ -6317,7 +6317,7 @@
         </p:nvSpPr>
         <p:spPr>
           <a:xfrm>
-            <a:off x="3176924" y="4386948"/>
+            <a:off x="3176924" y="4545645"/>
             <a:ext cx="8292316" cy="369332"/>
           </a:xfrm>
         </p:spPr>
@@ -10002,7 +10002,7 @@
           <a:noFill/>
           <a:extLst>
             <a:ext uri="{909E8E84-426E-40dd-AFC4-6F175D3DCCD1}">
-              <a14:hiddenFill xmlns:a14="http://schemas.microsoft.com/office/drawing/2010/main" xmlns="">
+              <a14:hiddenFill xmlns="" xmlns:a14="http://schemas.microsoft.com/office/drawing/2010/main">
                 <a:solidFill>
                   <a:srgbClr val="FFFFFF"/>
                 </a:solidFill>
@@ -15259,7 +15259,7 @@
         </p:nvSpPr>
         <p:spPr>
           <a:xfrm>
-            <a:off x="363096" y="112911"/>
+            <a:off x="363096" y="411282"/>
             <a:ext cx="11372473" cy="914400"/>
           </a:xfrm>
         </p:spPr>
@@ -15292,7 +15292,7 @@
         </p:nvSpPr>
         <p:spPr>
           <a:xfrm>
-            <a:off x="409507" y="570111"/>
+            <a:off x="409507" y="868482"/>
             <a:ext cx="11369809" cy="4047778"/>
           </a:xfrm>
         </p:spPr>
@@ -15343,7 +15343,37 @@
             </a:pPr>
             <a:r>
               <a:rPr lang="en-US" sz="1600" b="1" dirty="0"/>
-              <a:t>The requested citation the overall tutorial is:</a:t>
+              <a:t>The requested citation the overall tutorial is: </a:t>
+            </a:r>
+            <a:r>
+              <a:rPr lang="en-US" sz="1600" dirty="0"/>
+              <a:t>Anshu Dubey and Akash Dhruv, Better Software for Science with High-Performance Computing tutorial, in </a:t>
+            </a:r>
+            <a:r>
+              <a:rPr lang="en-US" sz="1600" dirty="0" err="1"/>
+              <a:t>SupercomputingAsia</a:t>
+            </a:r>
+            <a:r>
+              <a:rPr lang="en-US" sz="1600" dirty="0"/>
+              <a:t> 2026 (SCA 2026)/The International Conference on High Performance Computing in Asia-Pacific Region 2026 (</a:t>
+            </a:r>
+            <a:r>
+              <a:rPr lang="en-US" sz="1600" dirty="0" err="1"/>
+              <a:t>HPCAsia</a:t>
+            </a:r>
+            <a:r>
+              <a:rPr lang="en-US" sz="1600" dirty="0"/>
+              <a:t> 2026), Osaka, Japan, 2026. DOI: </a:t>
+            </a:r>
+            <a:r>
+              <a:rPr lang="en-US" sz="1600" dirty="0">
+                <a:hlinkClick r:id="rId4"/>
+              </a:rPr>
+              <a:t>10.6084/m9.figshare.31130062</a:t>
+            </a:r>
+            <a:r>
+              <a:rPr lang="en-US" sz="1600" dirty="0"/>
+              <a:t>.</a:t>
             </a:r>
             <a:endParaRPr lang="en-US" sz="1600" b="0" i="0" dirty="0">
               <a:solidFill>
@@ -15406,11 +15436,15 @@
             </a:pPr>
             <a:r>
               <a:rPr lang="en-US" sz="1400" dirty="0"/>
-              <a:t>This work was supported by the U.S. Department of Energy Office of Science, Office of Advanced Scientific Computing Research (ASCR), and by the Exascale Computing Project (17-SC-20-SC), a collaborative effort of the U.S. Department of Energy Office of Science and the National Nuclear Security Administration</a:t>
-            </a:r>
-            <a:r>
-              <a:rPr lang="en-US" sz="1400" i="1" dirty="0"/>
-              <a:t>.</a:t>
+              <a:t>This work was supported by the U.S. Department of Energy, Office of Science, Office of Advanced Scientific Computing Research, Next-Generation Scientific Software Technologies (NGSST) and Scientific Discovery through Advanced Computing (</a:t>
+            </a:r>
+            <a:r>
+              <a:rPr lang="en-US" sz="1400" dirty="0" err="1"/>
+              <a:t>SciDAC</a:t>
+            </a:r>
+            <a:r>
+              <a:rPr lang="en-US" sz="1400" dirty="0"/>
+              <a:t>) programs.</a:t>
             </a:r>
           </a:p>
           <a:p>
@@ -15420,11 +15454,12 @@
               </a:spcBef>
             </a:pPr>
             <a:r>
-              <a:rPr lang="en-US" sz="1400" b="0" i="0" dirty="0">
-                <a:effectLst/>
-                <a:latin typeface="+mn-lt"/>
-              </a:rPr>
-              <a:t>This work was supported by the U.S. Department of Energy, Office of Science, Office of Advanced Scientific Computing Research, Next-Generation Scientific Software Technologies (NGSST) program.</a:t>
+              <a:rPr lang="en-US" sz="1400" dirty="0"/>
+              <a:t>This work was supported by the U.S. Department of Energy Office of Science, Office of Advanced Scientific Computing Research (ASCR), and by the Exascale Computing Project (17-SC-20-SC), a collaborative effort of the U.S. Department of Energy Office of Science and the National Nuclear Security Administration</a:t>
+            </a:r>
+            <a:r>
+              <a:rPr lang="en-US" sz="1400" i="1" dirty="0"/>
+              <a:t>.</a:t>
             </a:r>
           </a:p>
           <a:p>
@@ -15499,7 +15534,7 @@
           <p:nvPr/>
         </p:nvPicPr>
         <p:blipFill>
-          <a:blip r:embed="rId4">
+          <a:blip r:embed="rId5">
             <a:extLst>
               <a:ext uri="{28A0092B-C50C-407E-A947-70E740481C1C}">
                 <a14:useLocalDpi xmlns:a14="http://schemas.microsoft.com/office/drawing/2010/main" val="0"/>
@@ -15534,7 +15569,7 @@
     </p:spTree>
     <p:extLst>
       <p:ext uri="{BB962C8B-B14F-4D97-AF65-F5344CB8AC3E}">
-        <p14:creationId xmlns:p14="http://schemas.microsoft.com/office/powerpoint/2010/main" val="3134769787"/>
+        <p14:creationId xmlns:p14="http://schemas.microsoft.com/office/powerpoint/2010/main" val="978726433"/>
       </p:ext>
     </p:extLst>
   </p:cSld>
@@ -29369,7 +29404,7 @@
         </p:spPr>
         <p:txBody>
           <a:bodyPr>
-            <a:normAutofit fontScale="85000" lnSpcReduction="20000"/>
+            <a:normAutofit fontScale="70000" lnSpcReduction="20000"/>
           </a:bodyPr>
           <a:lstStyle/>
           <a:p>
@@ -29385,6 +29420,11 @@
             </a:endParaRPr>
           </a:p>
           <a:p>
+            <a:pPr>
+              <a:lnSpc>
+                <a:spcPct val="110000"/>
+              </a:lnSpc>
+            </a:pPr>
             <a:r>
               <a:rPr lang="en-US" dirty="0">
                 <a:highlight>
@@ -29441,6 +29481,11 @@
             </a:endParaRPr>
           </a:p>
           <a:p>
+            <a:pPr>
+              <a:lnSpc>
+                <a:spcPct val="110000"/>
+              </a:lnSpc>
+            </a:pPr>
             <a:r>
               <a:rPr lang="en-US" b="0" i="0" u="none" strike="noStrike" dirty="0">
                 <a:solidFill>
@@ -29563,6 +29608,11 @@
             </a:endParaRPr>
           </a:p>
           <a:p>
+            <a:pPr>
+              <a:lnSpc>
+                <a:spcPct val="110000"/>
+              </a:lnSpc>
+            </a:pPr>
             <a:r>
               <a:rPr lang="en-US" b="0" i="0" u="none" strike="noStrike" dirty="0">
                 <a:solidFill>
@@ -29662,6 +29712,11 @@
             </a:r>
           </a:p>
           <a:p>
+            <a:pPr>
+              <a:lnSpc>
+                <a:spcPct val="110000"/>
+              </a:lnSpc>
+            </a:pPr>
             <a:r>
               <a:rPr lang="en-US" b="0" i="0" u="none" strike="noStrike" dirty="0">
                 <a:solidFill>
@@ -29745,6 +29800,11 @@
             </a:endParaRPr>
           </a:p>
           <a:p>
+            <a:pPr>
+              <a:lnSpc>
+                <a:spcPct val="110000"/>
+              </a:lnSpc>
+            </a:pPr>
             <a:r>
               <a:rPr lang="en-US" b="0" i="0" u="none" strike="noStrike" dirty="0">
                 <a:solidFill>
@@ -34270,18 +34330,18 @@
 </file>
 
 <file path=customXml/item1.xml><?xml version="1.0" encoding="utf-8"?>
+<p:properties xmlns:p="http://schemas.microsoft.com/office/2006/metadata/properties" xmlns:xsi="http://www.w3.org/2001/XMLSchema-instance" xmlns:pc="http://schemas.microsoft.com/office/infopath/2007/PartnerControls">
+  <documentManagement/>
+</p:properties>
+</file>
+
+<file path=customXml/item2.xml><?xml version="1.0" encoding="utf-8"?>
 <?mso-contentType ?>
 <FormTemplates xmlns="http://schemas.microsoft.com/sharepoint/v3/contenttype/forms">
   <Display>DocumentLibraryForm</Display>
   <Edit>DocumentLibraryForm</Edit>
   <New>DocumentLibraryForm</New>
 </FormTemplates>
-</file>
-
-<file path=customXml/item2.xml><?xml version="1.0" encoding="utf-8"?>
-<p:properties xmlns:p="http://schemas.microsoft.com/office/2006/metadata/properties" xmlns:xsi="http://www.w3.org/2001/XMLSchema-instance" xmlns:pc="http://schemas.microsoft.com/office/infopath/2007/PartnerControls">
-  <documentManagement/>
-</p:properties>
 </file>
 
 <file path=customXml/item3.xml><?xml version="1.0" encoding="utf-8"?>
@@ -34334,14 +34394,6 @@
 </file>
 
 <file path=customXml/itemProps1.xml><?xml version="1.0" encoding="utf-8"?>
-<ds:datastoreItem xmlns:ds="http://schemas.openxmlformats.org/officeDocument/2006/customXml" ds:itemID="{19E20559-B232-4371-8690-E3D8007EDB82}">
-  <ds:schemaRefs>
-    <ds:schemaRef ds:uri="http://schemas.microsoft.com/sharepoint/v3/contenttype/forms"/>
-  </ds:schemaRefs>
-</ds:datastoreItem>
-</file>
-
-<file path=customXml/itemProps2.xml><?xml version="1.0" encoding="utf-8"?>
 <ds:datastoreItem xmlns:ds="http://schemas.openxmlformats.org/officeDocument/2006/customXml" ds:itemID="{A50EC660-24D0-43A0-AE5E-E274115E726B}">
   <ds:schemaRefs>
     <ds:schemaRef ds:uri="http://purl.org/dc/elements/1.1/"/>
@@ -34352,6 +34404,14 @@
     <ds:schemaRef ds:uri="http://www.w3.org/XML/1998/namespace"/>
     <ds:schemaRef ds:uri="http://purl.org/dc/dcmitype/"/>
     <ds:schemaRef ds:uri="http://schemas.microsoft.com/office/infopath/2007/PartnerControls"/>
+  </ds:schemaRefs>
+</ds:datastoreItem>
+</file>
+
+<file path=customXml/itemProps2.xml><?xml version="1.0" encoding="utf-8"?>
+<ds:datastoreItem xmlns:ds="http://schemas.openxmlformats.org/officeDocument/2006/customXml" ds:itemID="{19E20559-B232-4371-8690-E3D8007EDB82}">
+  <ds:schemaRefs>
+    <ds:schemaRef ds:uri="http://schemas.microsoft.com/sharepoint/v3/contenttype/forms"/>
   </ds:schemaRefs>
 </ds:datastoreItem>
 </file>

</xml_diff>

<commit_message>
Update design for ATPESC 2026
</commit_message>
<xml_diff>
--- a/design.pptx
+++ b/design.pptx
@@ -12,7 +12,7 @@
   </p:handoutMasterIdLst>
   <p:sldIdLst>
     <p:sldId id="5601" r:id="rId5"/>
-    <p:sldId id="320" r:id="rId6"/>
+    <p:sldId id="5685" r:id="rId6"/>
     <p:sldId id="5590" r:id="rId7"/>
     <p:sldId id="5577" r:id="rId8"/>
     <p:sldId id="5591" r:id="rId9"/>
@@ -290,7 +290,7 @@
           <a:p>
             <a:fld id="{0B842F42-2CE9-4E35-95C1-410DC08A50B1}" type="datetimeFigureOut">
               <a:rPr lang="en-US" smtClean="0"/>
-              <a:t>1/23/2026</a:t>
+              <a:t>8/2/2026</a:t>
             </a:fld>
             <a:endParaRPr lang="en-US"/>
           </a:p>
@@ -455,7 +455,7 @@
           <a:p>
             <a:fld id="{6F282904-F315-4730-8D91-37D99E141A6F}" type="datetimeFigureOut">
               <a:rPr lang="en-US" smtClean="0"/>
-              <a:t>1/23/2026</a:t>
+              <a:t>8/2/2026</a:t>
             </a:fld>
             <a:endParaRPr lang="en-US"/>
           </a:p>
@@ -1635,42 +1635,6 @@
       </p:sp>
       <p:pic>
         <p:nvPicPr>
-          <p:cNvPr id="3" name="Picture 2">
-            <a:extLst>
-              <a:ext uri="{FF2B5EF4-FFF2-40B4-BE49-F238E27FC236}">
-                <a16:creationId xmlns:a16="http://schemas.microsoft.com/office/drawing/2014/main" id="{E5A81C43-A5B9-D933-9CA0-B9EBBA5B6295}"/>
-              </a:ext>
-            </a:extLst>
-          </p:cNvPr>
-          <p:cNvPicPr>
-            <a:picLocks noChangeAspect="1"/>
-          </p:cNvPicPr>
-          <p:nvPr userDrawn="1"/>
-        </p:nvPicPr>
-        <p:blipFill>
-          <a:blip r:embed="rId3" cstate="print">
-            <a:extLst>
-              <a:ext uri="{28A0092B-C50C-407E-A947-70E740481C1C}">
-                <a14:useLocalDpi xmlns:a14="http://schemas.microsoft.com/office/drawing/2010/main" val="0"/>
-              </a:ext>
-            </a:extLst>
-          </a:blip>
-          <a:stretch>
-            <a:fillRect/>
-          </a:stretch>
-        </p:blipFill>
-        <p:spPr>
-          <a:xfrm>
-            <a:off x="418659" y="158509"/>
-            <a:ext cx="2109916" cy="905256"/>
-          </a:xfrm>
-          <a:prstGeom prst="rect">
-            <a:avLst/>
-          </a:prstGeom>
-        </p:spPr>
-      </p:pic>
-      <p:pic>
-        <p:nvPicPr>
           <p:cNvPr id="8" name="Picture 7">
             <a:extLst>
               <a:ext uri="{FF2B5EF4-FFF2-40B4-BE49-F238E27FC236}">
@@ -1684,11 +1648,11 @@
           <p:nvPr userDrawn="1"/>
         </p:nvPicPr>
         <p:blipFill>
-          <a:blip r:embed="rId4" cstate="print">
+          <a:blip r:embed="rId3" cstate="print">
             <a:extLst>
               <a:ext uri="{BEBA8EAE-BF5A-486C-A8C5-ECC9F3942E4B}">
                 <a14:imgProps xmlns:a14="http://schemas.microsoft.com/office/drawing/2010/main">
-                  <a14:imgLayer r:embed="rId5">
+                  <a14:imgLayer r:embed="rId4">
                     <a14:imgEffect>
                       <a14:brightnessContrast bright="100000"/>
                     </a14:imgEffect>
@@ -1714,12 +1678,48 @@
           </a:prstGeom>
         </p:spPr>
       </p:pic>
+      <p:pic>
+        <p:nvPicPr>
+          <p:cNvPr id="10" name="Picture 9">
+            <a:extLst>
+              <a:ext uri="{FF2B5EF4-FFF2-40B4-BE49-F238E27FC236}">
+                <a16:creationId xmlns:a16="http://schemas.microsoft.com/office/drawing/2014/main" id="{02C27BA6-F3A8-60EC-3576-564A59264A22}"/>
+              </a:ext>
+            </a:extLst>
+          </p:cNvPr>
+          <p:cNvPicPr>
+            <a:picLocks noChangeAspect="1"/>
+          </p:cNvPicPr>
+          <p:nvPr userDrawn="1"/>
+        </p:nvPicPr>
+        <p:blipFill>
+          <a:blip r:embed="rId5" cstate="print">
+            <a:extLst>
+              <a:ext uri="{28A0092B-C50C-407E-A947-70E740481C1C}">
+                <a14:useLocalDpi xmlns:a14="http://schemas.microsoft.com/office/drawing/2010/main" val="0"/>
+              </a:ext>
+            </a:extLst>
+          </a:blip>
+          <a:stretch>
+            <a:fillRect/>
+          </a:stretch>
+        </p:blipFill>
+        <p:spPr>
+          <a:xfrm>
+            <a:off x="296061" y="158509"/>
+            <a:ext cx="2109916" cy="905256"/>
+          </a:xfrm>
+          <a:prstGeom prst="rect">
+            <a:avLst/>
+          </a:prstGeom>
+        </p:spPr>
+      </p:pic>
       <p:sp>
         <p:nvSpPr>
-          <p:cNvPr id="5" name="TextBox 4">
+          <p:cNvPr id="19" name="TextBox 18">
             <a:extLst>
               <a:ext uri="{FF2B5EF4-FFF2-40B4-BE49-F238E27FC236}">
-                <a16:creationId xmlns:a16="http://schemas.microsoft.com/office/drawing/2014/main" id="{70DE7CB6-F30F-C5CF-E25E-4391CCD5730D}"/>
+                <a16:creationId xmlns:a16="http://schemas.microsoft.com/office/drawing/2014/main" id="{524593E8-6C1F-EE6F-09D0-8A0BB083F885}"/>
               </a:ext>
             </a:extLst>
           </p:cNvPr>
@@ -1728,7 +1728,7 @@
         </p:nvSpPr>
         <p:spPr>
           <a:xfrm>
-            <a:off x="901538" y="1454246"/>
+            <a:off x="778940" y="1454246"/>
             <a:ext cx="1144159" cy="350865"/>
           </a:xfrm>
           <a:prstGeom prst="rect">
@@ -1756,10 +1756,10 @@
       </p:sp>
       <p:sp>
         <p:nvSpPr>
-          <p:cNvPr id="7" name="TextBox 6">
+          <p:cNvPr id="24" name="TextBox 23">
             <a:extLst>
               <a:ext uri="{FF2B5EF4-FFF2-40B4-BE49-F238E27FC236}">
-                <a16:creationId xmlns:a16="http://schemas.microsoft.com/office/drawing/2014/main" id="{CC09E9D5-5216-A587-FA6B-B65A405C06B8}"/>
+                <a16:creationId xmlns:a16="http://schemas.microsoft.com/office/drawing/2014/main" id="{A7F88FF6-622C-3D77-10C9-24C0DAC6A64A}"/>
               </a:ext>
             </a:extLst>
           </p:cNvPr>
@@ -1768,8 +1768,8 @@
         </p:nvSpPr>
         <p:spPr>
           <a:xfrm>
-            <a:off x="948025" y="2646131"/>
-            <a:ext cx="1051185" cy="350865"/>
+            <a:off x="863899" y="2646131"/>
+            <a:ext cx="974241" cy="350865"/>
           </a:xfrm>
           <a:prstGeom prst="rect">
             <a:avLst/>
@@ -1789,17 +1789,17 @@
             </a:pPr>
             <a:r>
               <a:rPr lang="en-US" sz="1200" i="1" dirty="0"/>
-              <a:t>Members of</a:t>
+              <a:t>Member of</a:t>
             </a:r>
           </a:p>
         </p:txBody>
       </p:sp>
       <p:sp>
         <p:nvSpPr>
-          <p:cNvPr id="12" name="TextBox 11">
+          <p:cNvPr id="26" name="TextBox 25">
             <a:extLst>
               <a:ext uri="{FF2B5EF4-FFF2-40B4-BE49-F238E27FC236}">
-                <a16:creationId xmlns:a16="http://schemas.microsoft.com/office/drawing/2014/main" id="{E2AEC599-063B-72D6-2F66-83A252291F05}"/>
+                <a16:creationId xmlns:a16="http://schemas.microsoft.com/office/drawing/2014/main" id="{71639705-DB52-A297-073A-94DA11375A52}"/>
               </a:ext>
             </a:extLst>
           </p:cNvPr>
@@ -1808,7 +1808,7 @@
         </p:nvSpPr>
         <p:spPr>
           <a:xfrm>
-            <a:off x="572120" y="4624321"/>
+            <a:off x="449522" y="4624321"/>
             <a:ext cx="1802994" cy="350865"/>
           </a:xfrm>
           <a:prstGeom prst="rect">
@@ -1836,10 +1836,10 @@
       </p:sp>
       <p:grpSp>
         <p:nvGrpSpPr>
-          <p:cNvPr id="15" name="Group 14">
+          <p:cNvPr id="27" name="Group 26">
             <a:extLst>
               <a:ext uri="{FF2B5EF4-FFF2-40B4-BE49-F238E27FC236}">
-                <a16:creationId xmlns:a16="http://schemas.microsoft.com/office/drawing/2014/main" id="{90A37BF6-6462-FB3C-25B7-EBAED4084920}"/>
+                <a16:creationId xmlns:a16="http://schemas.microsoft.com/office/drawing/2014/main" id="{189D78DD-9980-15E2-758B-FF02499BDF6A}"/>
               </a:ext>
             </a:extLst>
           </p:cNvPr>
@@ -1848,7 +1848,7 @@
         </p:nvGrpSpPr>
         <p:grpSpPr>
           <a:xfrm>
-            <a:off x="355043" y="5027111"/>
+            <a:off x="232445" y="5027111"/>
             <a:ext cx="2237149" cy="457200"/>
             <a:chOff x="343050" y="5128711"/>
             <a:chExt cx="2237149" cy="457200"/>
@@ -1856,10 +1856,10 @@
         </p:grpSpPr>
         <p:pic>
           <p:nvPicPr>
-            <p:cNvPr id="16" name="Picture 15">
+            <p:cNvPr id="28" name="Picture 27">
               <a:extLst>
                 <a:ext uri="{FF2B5EF4-FFF2-40B4-BE49-F238E27FC236}">
-                  <a16:creationId xmlns:a16="http://schemas.microsoft.com/office/drawing/2014/main" id="{3CF6C489-330D-1278-20B1-372463970242}"/>
+                  <a16:creationId xmlns:a16="http://schemas.microsoft.com/office/drawing/2014/main" id="{938752A1-F0E7-816C-D172-EB4DBDAE9C4D}"/>
                 </a:ext>
               </a:extLst>
             </p:cNvPr>
@@ -1892,10 +1892,10 @@
         </p:pic>
         <p:pic>
           <p:nvPicPr>
-            <p:cNvPr id="17" name="Picture 16" descr="A picture containing shape&#10;&#10;Description automatically generated">
+            <p:cNvPr id="29" name="Picture 28" descr="A picture containing shape&#10;&#10;Description automatically generated">
               <a:extLst>
                 <a:ext uri="{FF2B5EF4-FFF2-40B4-BE49-F238E27FC236}">
-                  <a16:creationId xmlns:a16="http://schemas.microsoft.com/office/drawing/2014/main" id="{F40C9257-5EAE-C91D-373B-1E76599701D5}"/>
+                  <a16:creationId xmlns:a16="http://schemas.microsoft.com/office/drawing/2014/main" id="{340F8317-8F8D-1AD4-3CD1-E2A5D729EF9D}"/>
                 </a:ext>
               </a:extLst>
             </p:cNvPr>
@@ -1927,213 +1927,59 @@
           </p:spPr>
         </p:pic>
       </p:grpSp>
-      <p:grpSp>
-        <p:nvGrpSpPr>
-          <p:cNvPr id="18" name="Group 17">
+      <p:pic>
+        <p:nvPicPr>
+          <p:cNvPr id="35" name="Picture 2" descr="A picture containing graphics, logo, font, symbol&#10;&#10;Description automatically generated">
             <a:extLst>
               <a:ext uri="{FF2B5EF4-FFF2-40B4-BE49-F238E27FC236}">
-                <a16:creationId xmlns:a16="http://schemas.microsoft.com/office/drawing/2014/main" id="{CC6A95BF-1A0C-F1C7-F23F-706A76F87CA6}"/>
+                <a16:creationId xmlns:a16="http://schemas.microsoft.com/office/drawing/2014/main" id="{C2429F9C-40AB-0CFB-94EA-4039B3E3D090}"/>
               </a:ext>
             </a:extLst>
           </p:cNvPr>
-          <p:cNvGrpSpPr/>
+          <p:cNvPicPr>
+            <a:picLocks noChangeAspect="1" noChangeArrowheads="1"/>
+          </p:cNvPicPr>
           <p:nvPr userDrawn="1"/>
-        </p:nvGrpSpPr>
-        <p:grpSpPr>
-          <a:xfrm>
-            <a:off x="-69503" y="1892144"/>
-            <a:ext cx="2985270" cy="790169"/>
-            <a:chOff x="-69503" y="2214872"/>
-            <a:chExt cx="2985270" cy="790169"/>
-          </a:xfrm>
-        </p:grpSpPr>
-        <p:pic>
-          <p:nvPicPr>
-            <p:cNvPr id="25" name="Picture 4">
-              <a:extLst>
-                <a:ext uri="{FF2B5EF4-FFF2-40B4-BE49-F238E27FC236}">
-                  <a16:creationId xmlns:a16="http://schemas.microsoft.com/office/drawing/2014/main" id="{25B0F52F-61EC-E67A-BEE5-AE883521C737}"/>
-                </a:ext>
-              </a:extLst>
-            </p:cNvPr>
-            <p:cNvPicPr>
-              <a:picLocks noChangeAspect="1" noChangeArrowheads="1"/>
-            </p:cNvPicPr>
-            <p:nvPr userDrawn="1"/>
-          </p:nvPicPr>
-          <p:blipFill>
-            <a:blip r:embed="rId8" cstate="print">
-              <a:extLst>
-                <a:ext uri="{28A0092B-C50C-407E-A947-70E740481C1C}">
-                  <a14:useLocalDpi xmlns:a14="http://schemas.microsoft.com/office/drawing/2010/main" val="0"/>
-                </a:ext>
-              </a:extLst>
-            </a:blip>
-            <a:srcRect/>
-            <a:stretch>
-              <a:fillRect/>
-            </a:stretch>
-          </p:blipFill>
-          <p:spPr bwMode="auto">
-            <a:xfrm>
-              <a:off x="1484438" y="2317122"/>
-              <a:ext cx="1371600" cy="318873"/>
-            </a:xfrm>
-            <a:prstGeom prst="rect">
-              <a:avLst/>
-            </a:prstGeom>
-            <a:noFill/>
+        </p:nvPicPr>
+        <p:blipFill>
+          <a:blip r:embed="rId8" cstate="print">
             <a:extLst>
-              <a:ext uri="{909E8E84-426E-40DD-AFC4-6F175D3DCCD1}">
-                <a14:hiddenFill xmlns:a14="http://schemas.microsoft.com/office/drawing/2010/main">
-                  <a:solidFill>
-                    <a:srgbClr val="FFFFFF"/>
-                  </a:solidFill>
-                </a14:hiddenFill>
+              <a:ext uri="{28A0092B-C50C-407E-A947-70E740481C1C}">
+                <a14:useLocalDpi xmlns:a14="http://schemas.microsoft.com/office/drawing/2010/main" val="0"/>
               </a:ext>
             </a:extLst>
-          </p:spPr>
-        </p:pic>
-        <p:pic>
-          <p:nvPicPr>
-            <p:cNvPr id="30" name="Picture 2" descr="A picture containing graphics, logo, font, symbol&#10;&#10;Description automatically generated">
-              <a:extLst>
-                <a:ext uri="{FF2B5EF4-FFF2-40B4-BE49-F238E27FC236}">
-                  <a16:creationId xmlns:a16="http://schemas.microsoft.com/office/drawing/2014/main" id="{A9BB0698-1E6E-118B-C4E9-35B9D67F5DB9}"/>
-                </a:ext>
-              </a:extLst>
-            </p:cNvPr>
-            <p:cNvPicPr>
-              <a:picLocks noChangeAspect="1" noChangeArrowheads="1"/>
-            </p:cNvPicPr>
-            <p:nvPr userDrawn="1"/>
-          </p:nvPicPr>
-          <p:blipFill>
-            <a:blip r:embed="rId9" cstate="print">
-              <a:extLst>
-                <a:ext uri="{28A0092B-C50C-407E-A947-70E740481C1C}">
-                  <a14:useLocalDpi xmlns:a14="http://schemas.microsoft.com/office/drawing/2010/main" val="0"/>
-                </a:ext>
-              </a:extLst>
-            </a:blip>
-            <a:srcRect/>
-            <a:stretch>
-              <a:fillRect/>
-            </a:stretch>
-          </p:blipFill>
-          <p:spPr bwMode="auto">
-            <a:xfrm>
-              <a:off x="321595" y="2214872"/>
-              <a:ext cx="841248" cy="523372"/>
-            </a:xfrm>
-            <a:prstGeom prst="rect">
-              <a:avLst/>
-            </a:prstGeom>
-            <a:noFill/>
-            <a:extLst>
-              <a:ext uri="{909E8E84-426E-40DD-AFC4-6F175D3DCCD1}">
-                <a14:hiddenFill xmlns:a14="http://schemas.microsoft.com/office/drawing/2010/main">
-                  <a:solidFill>
-                    <a:srgbClr val="FFFFFF"/>
-                  </a:solidFill>
-                </a14:hiddenFill>
-              </a:ext>
-            </a:extLst>
-          </p:spPr>
-        </p:pic>
-        <p:sp>
-          <p:nvSpPr>
-            <p:cNvPr id="31" name="TextBox 30">
-              <a:extLst>
-                <a:ext uri="{FF2B5EF4-FFF2-40B4-BE49-F238E27FC236}">
-                  <a16:creationId xmlns:a16="http://schemas.microsoft.com/office/drawing/2014/main" id="{D9F57AC4-079D-30A9-F299-0EAF3ECA2772}"/>
-                </a:ext>
-              </a:extLst>
-            </p:cNvPr>
-            <p:cNvSpPr txBox="1"/>
-            <p:nvPr userDrawn="1"/>
-          </p:nvSpPr>
-          <p:spPr>
-            <a:xfrm>
-              <a:off x="-69503" y="2668026"/>
-              <a:ext cx="1631472" cy="337015"/>
-            </a:xfrm>
-            <a:prstGeom prst="rect">
-              <a:avLst/>
-            </a:prstGeom>
-            <a:noFill/>
-          </p:spPr>
-          <p:txBody>
-            <a:bodyPr wrap="none" lIns="118872" tIns="91440" rIns="118872" bIns="91440" rtlCol="0" anchor="ctr" anchorCtr="0">
-              <a:spAutoFit/>
-            </a:bodyPr>
-            <a:lstStyle/>
-            <a:p>
-              <a:pPr algn="l">
-                <a:lnSpc>
-                  <a:spcPct val="90000"/>
-                </a:lnSpc>
-              </a:pPr>
-              <a:r>
-                <a:rPr lang="en-US" sz="1050" i="1" dirty="0">
-                  <a:hlinkClick r:id="rId10"/>
-                </a:rPr>
-                <a:t>https://pesoproject.org</a:t>
-              </a:r>
-              <a:endParaRPr lang="en-US" sz="1050" i="1" dirty="0"/>
-            </a:p>
-          </p:txBody>
-        </p:sp>
-        <p:sp>
-          <p:nvSpPr>
-            <p:cNvPr id="32" name="TextBox 31">
-              <a:extLst>
-                <a:ext uri="{FF2B5EF4-FFF2-40B4-BE49-F238E27FC236}">
-                  <a16:creationId xmlns:a16="http://schemas.microsoft.com/office/drawing/2014/main" id="{CA5C2C8A-9502-60F5-68E1-3296B30C2880}"/>
-                </a:ext>
-              </a:extLst>
-            </p:cNvPr>
-            <p:cNvSpPr txBox="1"/>
-            <p:nvPr userDrawn="1"/>
-          </p:nvSpPr>
-          <p:spPr>
-            <a:xfrm>
-              <a:off x="1423755" y="2668026"/>
-              <a:ext cx="1492012" cy="337015"/>
-            </a:xfrm>
-            <a:prstGeom prst="rect">
-              <a:avLst/>
-            </a:prstGeom>
-            <a:noFill/>
-          </p:spPr>
-          <p:txBody>
-            <a:bodyPr wrap="none" lIns="118872" tIns="91440" rIns="118872" bIns="91440" rtlCol="0" anchor="ctr" anchorCtr="0">
-              <a:spAutoFit/>
-            </a:bodyPr>
-            <a:lstStyle/>
-            <a:p>
-              <a:pPr algn="l">
-                <a:lnSpc>
-                  <a:spcPct val="90000"/>
-                </a:lnSpc>
-              </a:pPr>
-              <a:r>
-                <a:rPr lang="en-US" sz="1050" i="1" dirty="0">
-                  <a:hlinkClick r:id="rId11"/>
-                </a:rPr>
-                <a:t>https://rapids.lbl.gov</a:t>
-              </a:r>
-              <a:endParaRPr lang="en-US" sz="1050" i="1" dirty="0"/>
-            </a:p>
-          </p:txBody>
-        </p:sp>
-      </p:grpSp>
+          </a:blip>
+          <a:srcRect/>
+          <a:stretch>
+            <a:fillRect/>
+          </a:stretch>
+        </p:blipFill>
+        <p:spPr bwMode="auto">
+          <a:xfrm>
+            <a:off x="930395" y="1892144"/>
+            <a:ext cx="841248" cy="523372"/>
+          </a:xfrm>
+          <a:prstGeom prst="rect">
+            <a:avLst/>
+          </a:prstGeom>
+          <a:noFill/>
+          <a:extLst>
+            <a:ext uri="{909E8E84-426E-40DD-AFC4-6F175D3DCCD1}">
+              <a14:hiddenFill xmlns:a14="http://schemas.microsoft.com/office/drawing/2010/main">
+                <a:solidFill>
+                  <a:srgbClr val="FFFFFF"/>
+                </a:solidFill>
+              </a14:hiddenFill>
+            </a:ext>
+          </a:extLst>
+        </p:spPr>
+      </p:pic>
       <p:sp>
         <p:nvSpPr>
-          <p:cNvPr id="33" name="TextBox 32">
+          <p:cNvPr id="36" name="TextBox 35">
             <a:extLst>
               <a:ext uri="{FF2B5EF4-FFF2-40B4-BE49-F238E27FC236}">
-                <a16:creationId xmlns:a16="http://schemas.microsoft.com/office/drawing/2014/main" id="{A7BFAE79-6B18-E222-E24F-73C71226E876}"/>
+                <a16:creationId xmlns:a16="http://schemas.microsoft.com/office/drawing/2014/main" id="{916850F0-0223-B306-59F8-475F55DBAD08}"/>
               </a:ext>
             </a:extLst>
           </p:cNvPr>
@@ -2142,7 +1988,50 @@
         </p:nvSpPr>
         <p:spPr>
           <a:xfrm>
-            <a:off x="166031" y="4011401"/>
+            <a:off x="535283" y="2345298"/>
+            <a:ext cx="1631472" cy="337015"/>
+          </a:xfrm>
+          <a:prstGeom prst="rect">
+            <a:avLst/>
+          </a:prstGeom>
+          <a:noFill/>
+        </p:spPr>
+        <p:txBody>
+          <a:bodyPr wrap="none" lIns="118872" tIns="91440" rIns="118872" bIns="91440" rtlCol="0" anchor="ctr" anchorCtr="0">
+            <a:spAutoFit/>
+          </a:bodyPr>
+          <a:lstStyle/>
+          <a:p>
+            <a:pPr algn="l">
+              <a:lnSpc>
+                <a:spcPct val="90000"/>
+              </a:lnSpc>
+            </a:pPr>
+            <a:r>
+              <a:rPr lang="en-US" sz="1050" i="1" dirty="0">
+                <a:hlinkClick r:id="rId9"/>
+              </a:rPr>
+              <a:t>https://pesoproject.org</a:t>
+            </a:r>
+            <a:endParaRPr lang="en-US" sz="1050" i="1" dirty="0"/>
+          </a:p>
+        </p:txBody>
+      </p:sp>
+      <p:sp>
+        <p:nvSpPr>
+          <p:cNvPr id="37" name="TextBox 36">
+            <a:extLst>
+              <a:ext uri="{FF2B5EF4-FFF2-40B4-BE49-F238E27FC236}">
+                <a16:creationId xmlns:a16="http://schemas.microsoft.com/office/drawing/2014/main" id="{BB3AB2A3-5824-04D8-C1BB-BF4371679814}"/>
+              </a:ext>
+            </a:extLst>
+          </p:cNvPr>
+          <p:cNvSpPr txBox="1"/>
+          <p:nvPr userDrawn="1"/>
+        </p:nvSpPr>
+        <p:spPr>
+          <a:xfrm>
+            <a:off x="48264" y="4011401"/>
             <a:ext cx="2605511" cy="655564"/>
           </a:xfrm>
           <a:prstGeom prst="rect">
@@ -2170,7 +2059,7 @@
             </a:br>
             <a:r>
               <a:rPr lang="en-US" sz="1000" i="1" dirty="0">
-                <a:hlinkClick r:id="rId12"/>
+                <a:hlinkClick r:id="rId10"/>
               </a:rPr>
               <a:t>https://cass.community</a:t>
             </a:r>
@@ -2180,10 +2069,10 @@
       </p:sp>
       <p:pic>
         <p:nvPicPr>
-          <p:cNvPr id="34" name="Picture 33" descr="A picture containing arrow&#10;&#10;AI-generated content may be incorrect.">
+          <p:cNvPr id="38" name="Picture 37" descr="A picture containing arrow&#10;&#10;AI-generated content may be incorrect.">
             <a:extLst>
               <a:ext uri="{FF2B5EF4-FFF2-40B4-BE49-F238E27FC236}">
-                <a16:creationId xmlns:a16="http://schemas.microsoft.com/office/drawing/2014/main" id="{D88D7312-C802-BE51-9FA0-6A6B23F22C0B}"/>
+                <a16:creationId xmlns:a16="http://schemas.microsoft.com/office/drawing/2014/main" id="{0AF9D7D5-ABF3-0AB8-BB3B-B57F9C5E0D61}"/>
               </a:ext>
             </a:extLst>
           </p:cNvPr>
@@ -2193,7 +2082,7 @@
           <p:nvPr userDrawn="1"/>
         </p:nvPicPr>
         <p:blipFill>
-          <a:blip r:embed="rId13" cstate="print">
+          <a:blip r:embed="rId11" cstate="print">
             <a:extLst>
               <a:ext uri="{28A0092B-C50C-407E-A947-70E740481C1C}">
                 <a14:useLocalDpi xmlns:a14="http://schemas.microsoft.com/office/drawing/2010/main" val="0"/>
@@ -2206,7 +2095,7 @@
         </p:blipFill>
         <p:spPr>
           <a:xfrm>
-            <a:off x="849769" y="2974535"/>
+            <a:off x="732002" y="2974535"/>
             <a:ext cx="1238034" cy="1128739"/>
           </a:xfrm>
           <a:prstGeom prst="rect">
@@ -2310,11 +2199,6 @@
             </a:lvl1pPr>
           </a:lstStyle>
           <a:p>
-            <a:fld id="{9CF5EF28-261C-FD41-A360-1A380056DD17}" type="slidenum">
-              <a:rPr lang="en-US" smtClean="0"/>
-              <a:pPr/>
-              <a:t>‹#›</a:t>
-            </a:fld>
             <a:endParaRPr lang="en-US" dirty="0"/>
           </a:p>
         </p:txBody>
@@ -2896,10 +2780,10 @@
       </p:sp>
       <p:pic>
         <p:nvPicPr>
-          <p:cNvPr id="5" name="Picture 4">
+          <p:cNvPr id="6" name="Picture 5">
             <a:extLst>
               <a:ext uri="{FF2B5EF4-FFF2-40B4-BE49-F238E27FC236}">
-                <a16:creationId xmlns:a16="http://schemas.microsoft.com/office/drawing/2014/main" id="{39A0B7EC-D4C0-0A37-EF93-54309C1E7E8C}"/>
+                <a16:creationId xmlns:a16="http://schemas.microsoft.com/office/drawing/2014/main" id="{E88094E3-275F-7583-2B12-C2BFF43C5029}"/>
               </a:ext>
             </a:extLst>
           </p:cNvPr>
@@ -2922,7 +2806,7 @@
         </p:blipFill>
         <p:spPr>
           <a:xfrm>
-            <a:off x="418659" y="158509"/>
+            <a:off x="296061" y="158509"/>
             <a:ext cx="2109916" cy="905256"/>
           </a:xfrm>
           <a:prstGeom prst="rect">
@@ -2932,10 +2816,10 @@
       </p:pic>
       <p:sp>
         <p:nvSpPr>
-          <p:cNvPr id="12" name="TextBox 11">
+          <p:cNvPr id="7" name="TextBox 6">
             <a:extLst>
               <a:ext uri="{FF2B5EF4-FFF2-40B4-BE49-F238E27FC236}">
-                <a16:creationId xmlns:a16="http://schemas.microsoft.com/office/drawing/2014/main" id="{1BC79204-B1FE-B3CE-9EA4-08178150AF2C}"/>
+                <a16:creationId xmlns:a16="http://schemas.microsoft.com/office/drawing/2014/main" id="{3194150A-2AED-77F8-8D25-5E96A04210EB}"/>
               </a:ext>
             </a:extLst>
           </p:cNvPr>
@@ -2944,7 +2828,7 @@
         </p:nvSpPr>
         <p:spPr>
           <a:xfrm>
-            <a:off x="901538" y="1454246"/>
+            <a:off x="778940" y="1454246"/>
             <a:ext cx="1144159" cy="350865"/>
           </a:xfrm>
           <a:prstGeom prst="rect">
@@ -2972,10 +2856,10 @@
       </p:sp>
       <p:sp>
         <p:nvSpPr>
-          <p:cNvPr id="19" name="TextBox 18">
+          <p:cNvPr id="8" name="TextBox 7">
             <a:extLst>
               <a:ext uri="{FF2B5EF4-FFF2-40B4-BE49-F238E27FC236}">
-                <a16:creationId xmlns:a16="http://schemas.microsoft.com/office/drawing/2014/main" id="{540AE08A-1688-EA24-31E1-990C11A652D2}"/>
+                <a16:creationId xmlns:a16="http://schemas.microsoft.com/office/drawing/2014/main" id="{4359E871-013D-5C3F-72FD-31564F2079B3}"/>
               </a:ext>
             </a:extLst>
           </p:cNvPr>
@@ -2984,8 +2868,8 @@
         </p:nvSpPr>
         <p:spPr>
           <a:xfrm>
-            <a:off x="948025" y="2646131"/>
-            <a:ext cx="1051185" cy="350865"/>
+            <a:off x="863899" y="2646131"/>
+            <a:ext cx="974241" cy="350865"/>
           </a:xfrm>
           <a:prstGeom prst="rect">
             <a:avLst/>
@@ -3005,17 +2889,17 @@
             </a:pPr>
             <a:r>
               <a:rPr lang="en-US" sz="1200" i="1" dirty="0"/>
-              <a:t>Members of</a:t>
+              <a:t>Member of</a:t>
             </a:r>
           </a:p>
         </p:txBody>
       </p:sp>
       <p:sp>
         <p:nvSpPr>
-          <p:cNvPr id="23" name="TextBox 22">
+          <p:cNvPr id="9" name="TextBox 8">
             <a:extLst>
               <a:ext uri="{FF2B5EF4-FFF2-40B4-BE49-F238E27FC236}">
-                <a16:creationId xmlns:a16="http://schemas.microsoft.com/office/drawing/2014/main" id="{817DDBF2-5B08-51D6-AF32-A3234C4A1BFA}"/>
+                <a16:creationId xmlns:a16="http://schemas.microsoft.com/office/drawing/2014/main" id="{83F659C8-9FE5-2835-15BE-C4612477CCF3}"/>
               </a:ext>
             </a:extLst>
           </p:cNvPr>
@@ -3024,7 +2908,7 @@
         </p:nvSpPr>
         <p:spPr>
           <a:xfrm>
-            <a:off x="572120" y="4624321"/>
+            <a:off x="449522" y="4624321"/>
             <a:ext cx="1802994" cy="350865"/>
           </a:xfrm>
           <a:prstGeom prst="rect">
@@ -3052,10 +2936,10 @@
       </p:sp>
       <p:grpSp>
         <p:nvGrpSpPr>
-          <p:cNvPr id="24" name="Group 23">
+          <p:cNvPr id="10" name="Group 9">
             <a:extLst>
               <a:ext uri="{FF2B5EF4-FFF2-40B4-BE49-F238E27FC236}">
-                <a16:creationId xmlns:a16="http://schemas.microsoft.com/office/drawing/2014/main" id="{6B00848E-3F23-BA04-676F-CE00B7BEAD31}"/>
+                <a16:creationId xmlns:a16="http://schemas.microsoft.com/office/drawing/2014/main" id="{F283840A-68C3-D7F2-21E7-764BB1CF0A6F}"/>
               </a:ext>
             </a:extLst>
           </p:cNvPr>
@@ -3064,7 +2948,7 @@
         </p:nvGrpSpPr>
         <p:grpSpPr>
           <a:xfrm>
-            <a:off x="355043" y="5027111"/>
+            <a:off x="232445" y="5027111"/>
             <a:ext cx="2237149" cy="457200"/>
             <a:chOff x="343050" y="5128711"/>
             <a:chExt cx="2237149" cy="457200"/>
@@ -3072,10 +2956,10 @@
         </p:grpSpPr>
         <p:pic>
           <p:nvPicPr>
-            <p:cNvPr id="25" name="Picture 24">
+            <p:cNvPr id="11" name="Picture 10">
               <a:extLst>
                 <a:ext uri="{FF2B5EF4-FFF2-40B4-BE49-F238E27FC236}">
-                  <a16:creationId xmlns:a16="http://schemas.microsoft.com/office/drawing/2014/main" id="{C6373EB4-0467-E2CD-A904-29721BF6E12A}"/>
+                  <a16:creationId xmlns:a16="http://schemas.microsoft.com/office/drawing/2014/main" id="{010A5413-C715-0B9E-A854-EE3C9EDCB754}"/>
                 </a:ext>
               </a:extLst>
             </p:cNvPr>
@@ -3108,10 +2992,10 @@
         </p:pic>
         <p:pic>
           <p:nvPicPr>
-            <p:cNvPr id="26" name="Picture 25" descr="A picture containing shape&#10;&#10;Description automatically generated">
+            <p:cNvPr id="15" name="Picture 14" descr="A picture containing shape&#10;&#10;Description automatically generated">
               <a:extLst>
                 <a:ext uri="{FF2B5EF4-FFF2-40B4-BE49-F238E27FC236}">
-                  <a16:creationId xmlns:a16="http://schemas.microsoft.com/office/drawing/2014/main" id="{74E24885-3320-7DE6-F3F3-EF61A8477440}"/>
+                  <a16:creationId xmlns:a16="http://schemas.microsoft.com/office/drawing/2014/main" id="{93B794FA-2A7D-9288-A453-788BBE449655}"/>
                 </a:ext>
               </a:extLst>
             </p:cNvPr>
@@ -3143,213 +3027,59 @@
           </p:spPr>
         </p:pic>
       </p:grpSp>
-      <p:grpSp>
-        <p:nvGrpSpPr>
-          <p:cNvPr id="27" name="Group 26">
+      <p:pic>
+        <p:nvPicPr>
+          <p:cNvPr id="17" name="Picture 2" descr="A picture containing graphics, logo, font, symbol&#10;&#10;Description automatically generated">
             <a:extLst>
               <a:ext uri="{FF2B5EF4-FFF2-40B4-BE49-F238E27FC236}">
-                <a16:creationId xmlns:a16="http://schemas.microsoft.com/office/drawing/2014/main" id="{578CBBCD-B85F-C77F-73CC-29DBBBEFD434}"/>
+                <a16:creationId xmlns:a16="http://schemas.microsoft.com/office/drawing/2014/main" id="{1C19FD13-9273-C7AA-0F09-45B4F5BCE584}"/>
               </a:ext>
             </a:extLst>
           </p:cNvPr>
-          <p:cNvGrpSpPr/>
+          <p:cNvPicPr>
+            <a:picLocks noChangeAspect="1" noChangeArrowheads="1"/>
+          </p:cNvPicPr>
           <p:nvPr userDrawn="1"/>
-        </p:nvGrpSpPr>
-        <p:grpSpPr>
-          <a:xfrm>
-            <a:off x="-69503" y="1892144"/>
-            <a:ext cx="2985270" cy="790169"/>
-            <a:chOff x="-69503" y="2214872"/>
-            <a:chExt cx="2985270" cy="790169"/>
-          </a:xfrm>
-        </p:grpSpPr>
-        <p:pic>
-          <p:nvPicPr>
-            <p:cNvPr id="28" name="Picture 4">
-              <a:extLst>
-                <a:ext uri="{FF2B5EF4-FFF2-40B4-BE49-F238E27FC236}">
-                  <a16:creationId xmlns:a16="http://schemas.microsoft.com/office/drawing/2014/main" id="{A695C840-7733-06CC-6313-CDA74D8B9956}"/>
-                </a:ext>
-              </a:extLst>
-            </p:cNvPr>
-            <p:cNvPicPr>
-              <a:picLocks noChangeAspect="1" noChangeArrowheads="1"/>
-            </p:cNvPicPr>
-            <p:nvPr userDrawn="1"/>
-          </p:nvPicPr>
-          <p:blipFill>
-            <a:blip r:embed="rId8" cstate="print">
-              <a:extLst>
-                <a:ext uri="{28A0092B-C50C-407E-A947-70E740481C1C}">
-                  <a14:useLocalDpi xmlns:a14="http://schemas.microsoft.com/office/drawing/2010/main" val="0"/>
-                </a:ext>
-              </a:extLst>
-            </a:blip>
-            <a:srcRect/>
-            <a:stretch>
-              <a:fillRect/>
-            </a:stretch>
-          </p:blipFill>
-          <p:spPr bwMode="auto">
-            <a:xfrm>
-              <a:off x="1484438" y="2317122"/>
-              <a:ext cx="1371600" cy="318873"/>
-            </a:xfrm>
-            <a:prstGeom prst="rect">
-              <a:avLst/>
-            </a:prstGeom>
-            <a:noFill/>
+        </p:nvPicPr>
+        <p:blipFill>
+          <a:blip r:embed="rId8" cstate="print">
             <a:extLst>
-              <a:ext uri="{909E8E84-426E-40DD-AFC4-6F175D3DCCD1}">
-                <a14:hiddenFill xmlns:a14="http://schemas.microsoft.com/office/drawing/2010/main">
-                  <a:solidFill>
-                    <a:srgbClr val="FFFFFF"/>
-                  </a:solidFill>
-                </a14:hiddenFill>
+              <a:ext uri="{28A0092B-C50C-407E-A947-70E740481C1C}">
+                <a14:useLocalDpi xmlns:a14="http://schemas.microsoft.com/office/drawing/2010/main" val="0"/>
               </a:ext>
             </a:extLst>
-          </p:spPr>
-        </p:pic>
-        <p:pic>
-          <p:nvPicPr>
-            <p:cNvPr id="29" name="Picture 2" descr="A picture containing graphics, logo, font, symbol&#10;&#10;Description automatically generated">
-              <a:extLst>
-                <a:ext uri="{FF2B5EF4-FFF2-40B4-BE49-F238E27FC236}">
-                  <a16:creationId xmlns:a16="http://schemas.microsoft.com/office/drawing/2014/main" id="{E9A196A8-BB8A-3FB8-7BB2-5D16AEE27D5D}"/>
-                </a:ext>
-              </a:extLst>
-            </p:cNvPr>
-            <p:cNvPicPr>
-              <a:picLocks noChangeAspect="1" noChangeArrowheads="1"/>
-            </p:cNvPicPr>
-            <p:nvPr userDrawn="1"/>
-          </p:nvPicPr>
-          <p:blipFill>
-            <a:blip r:embed="rId9" cstate="print">
-              <a:extLst>
-                <a:ext uri="{28A0092B-C50C-407E-A947-70E740481C1C}">
-                  <a14:useLocalDpi xmlns:a14="http://schemas.microsoft.com/office/drawing/2010/main" val="0"/>
-                </a:ext>
-              </a:extLst>
-            </a:blip>
-            <a:srcRect/>
-            <a:stretch>
-              <a:fillRect/>
-            </a:stretch>
-          </p:blipFill>
-          <p:spPr bwMode="auto">
-            <a:xfrm>
-              <a:off x="321595" y="2214872"/>
-              <a:ext cx="841248" cy="523372"/>
-            </a:xfrm>
-            <a:prstGeom prst="rect">
-              <a:avLst/>
-            </a:prstGeom>
-            <a:noFill/>
-            <a:extLst>
-              <a:ext uri="{909E8E84-426E-40DD-AFC4-6F175D3DCCD1}">
-                <a14:hiddenFill xmlns:a14="http://schemas.microsoft.com/office/drawing/2010/main">
-                  <a:solidFill>
-                    <a:srgbClr val="FFFFFF"/>
-                  </a:solidFill>
-                </a14:hiddenFill>
-              </a:ext>
-            </a:extLst>
-          </p:spPr>
-        </p:pic>
-        <p:sp>
-          <p:nvSpPr>
-            <p:cNvPr id="30" name="TextBox 29">
-              <a:extLst>
-                <a:ext uri="{FF2B5EF4-FFF2-40B4-BE49-F238E27FC236}">
-                  <a16:creationId xmlns:a16="http://schemas.microsoft.com/office/drawing/2014/main" id="{615945D9-6363-9514-7C4E-6E75FC9D15C7}"/>
-                </a:ext>
-              </a:extLst>
-            </p:cNvPr>
-            <p:cNvSpPr txBox="1"/>
-            <p:nvPr userDrawn="1"/>
-          </p:nvSpPr>
-          <p:spPr>
-            <a:xfrm>
-              <a:off x="-69503" y="2668026"/>
-              <a:ext cx="1631472" cy="337015"/>
-            </a:xfrm>
-            <a:prstGeom prst="rect">
-              <a:avLst/>
-            </a:prstGeom>
-            <a:noFill/>
-          </p:spPr>
-          <p:txBody>
-            <a:bodyPr wrap="none" lIns="118872" tIns="91440" rIns="118872" bIns="91440" rtlCol="0" anchor="ctr" anchorCtr="0">
-              <a:spAutoFit/>
-            </a:bodyPr>
-            <a:lstStyle/>
-            <a:p>
-              <a:pPr algn="l">
-                <a:lnSpc>
-                  <a:spcPct val="90000"/>
-                </a:lnSpc>
-              </a:pPr>
-              <a:r>
-                <a:rPr lang="en-US" sz="1050" i="1" dirty="0">
-                  <a:hlinkClick r:id="rId10"/>
-                </a:rPr>
-                <a:t>https://pesoproject.org</a:t>
-              </a:r>
-              <a:endParaRPr lang="en-US" sz="1050" i="1" dirty="0"/>
-            </a:p>
-          </p:txBody>
-        </p:sp>
-        <p:sp>
-          <p:nvSpPr>
-            <p:cNvPr id="31" name="TextBox 30">
-              <a:extLst>
-                <a:ext uri="{FF2B5EF4-FFF2-40B4-BE49-F238E27FC236}">
-                  <a16:creationId xmlns:a16="http://schemas.microsoft.com/office/drawing/2014/main" id="{2956306F-B98B-1D3E-A678-C01A178BDF63}"/>
-                </a:ext>
-              </a:extLst>
-            </p:cNvPr>
-            <p:cNvSpPr txBox="1"/>
-            <p:nvPr userDrawn="1"/>
-          </p:nvSpPr>
-          <p:spPr>
-            <a:xfrm>
-              <a:off x="1423755" y="2668026"/>
-              <a:ext cx="1492012" cy="337015"/>
-            </a:xfrm>
-            <a:prstGeom prst="rect">
-              <a:avLst/>
-            </a:prstGeom>
-            <a:noFill/>
-          </p:spPr>
-          <p:txBody>
-            <a:bodyPr wrap="none" lIns="118872" tIns="91440" rIns="118872" bIns="91440" rtlCol="0" anchor="ctr" anchorCtr="0">
-              <a:spAutoFit/>
-            </a:bodyPr>
-            <a:lstStyle/>
-            <a:p>
-              <a:pPr algn="l">
-                <a:lnSpc>
-                  <a:spcPct val="90000"/>
-                </a:lnSpc>
-              </a:pPr>
-              <a:r>
-                <a:rPr lang="en-US" sz="1050" i="1" dirty="0">
-                  <a:hlinkClick r:id="rId11"/>
-                </a:rPr>
-                <a:t>https://rapids.lbl.gov</a:t>
-              </a:r>
-              <a:endParaRPr lang="en-US" sz="1050" i="1" dirty="0"/>
-            </a:p>
-          </p:txBody>
-        </p:sp>
-      </p:grpSp>
+          </a:blip>
+          <a:srcRect/>
+          <a:stretch>
+            <a:fillRect/>
+          </a:stretch>
+        </p:blipFill>
+        <p:spPr bwMode="auto">
+          <a:xfrm>
+            <a:off x="930395" y="1892144"/>
+            <a:ext cx="841248" cy="523372"/>
+          </a:xfrm>
+          <a:prstGeom prst="rect">
+            <a:avLst/>
+          </a:prstGeom>
+          <a:noFill/>
+          <a:extLst>
+            <a:ext uri="{909E8E84-426E-40DD-AFC4-6F175D3DCCD1}">
+              <a14:hiddenFill xmlns:a14="http://schemas.microsoft.com/office/drawing/2010/main">
+                <a:solidFill>
+                  <a:srgbClr val="FFFFFF"/>
+                </a:solidFill>
+              </a14:hiddenFill>
+            </a:ext>
+          </a:extLst>
+        </p:spPr>
+      </p:pic>
       <p:sp>
         <p:nvSpPr>
-          <p:cNvPr id="32" name="TextBox 31">
+          <p:cNvPr id="18" name="TextBox 17">
             <a:extLst>
               <a:ext uri="{FF2B5EF4-FFF2-40B4-BE49-F238E27FC236}">
-                <a16:creationId xmlns:a16="http://schemas.microsoft.com/office/drawing/2014/main" id="{EC239939-96E2-AD74-8BAE-BA514F5CF767}"/>
+                <a16:creationId xmlns:a16="http://schemas.microsoft.com/office/drawing/2014/main" id="{B0A1EAD5-C03A-E501-AE24-A084D44EBA26}"/>
               </a:ext>
             </a:extLst>
           </p:cNvPr>
@@ -3358,7 +3088,50 @@
         </p:nvSpPr>
         <p:spPr>
           <a:xfrm>
-            <a:off x="166031" y="4011401"/>
+            <a:off x="535283" y="2345298"/>
+            <a:ext cx="1631472" cy="337015"/>
+          </a:xfrm>
+          <a:prstGeom prst="rect">
+            <a:avLst/>
+          </a:prstGeom>
+          <a:noFill/>
+        </p:spPr>
+        <p:txBody>
+          <a:bodyPr wrap="none" lIns="118872" tIns="91440" rIns="118872" bIns="91440" rtlCol="0" anchor="ctr" anchorCtr="0">
+            <a:spAutoFit/>
+          </a:bodyPr>
+          <a:lstStyle/>
+          <a:p>
+            <a:pPr algn="l">
+              <a:lnSpc>
+                <a:spcPct val="90000"/>
+              </a:lnSpc>
+            </a:pPr>
+            <a:r>
+              <a:rPr lang="en-US" sz="1050" i="1" dirty="0">
+                <a:hlinkClick r:id="rId9"/>
+              </a:rPr>
+              <a:t>https://pesoproject.org</a:t>
+            </a:r>
+            <a:endParaRPr lang="en-US" sz="1050" i="1" dirty="0"/>
+          </a:p>
+        </p:txBody>
+      </p:sp>
+      <p:sp>
+        <p:nvSpPr>
+          <p:cNvPr id="20" name="TextBox 19">
+            <a:extLst>
+              <a:ext uri="{FF2B5EF4-FFF2-40B4-BE49-F238E27FC236}">
+                <a16:creationId xmlns:a16="http://schemas.microsoft.com/office/drawing/2014/main" id="{F5F320F6-3AB1-591B-3D2A-9EE5E3F1FF33}"/>
+              </a:ext>
+            </a:extLst>
+          </p:cNvPr>
+          <p:cNvSpPr txBox="1"/>
+          <p:nvPr userDrawn="1"/>
+        </p:nvSpPr>
+        <p:spPr>
+          <a:xfrm>
+            <a:off x="48264" y="4011401"/>
             <a:ext cx="2605511" cy="655564"/>
           </a:xfrm>
           <a:prstGeom prst="rect">
@@ -3386,7 +3159,7 @@
             </a:br>
             <a:r>
               <a:rPr lang="en-US" sz="1000" i="1" dirty="0">
-                <a:hlinkClick r:id="rId12"/>
+                <a:hlinkClick r:id="rId10"/>
               </a:rPr>
               <a:t>https://cass.community</a:t>
             </a:r>
@@ -3396,10 +3169,10 @@
       </p:sp>
       <p:pic>
         <p:nvPicPr>
-          <p:cNvPr id="33" name="Picture 32" descr="A picture containing arrow&#10;&#10;AI-generated content may be incorrect.">
+          <p:cNvPr id="21" name="Picture 20" descr="A picture containing arrow&#10;&#10;AI-generated content may be incorrect.">
             <a:extLst>
               <a:ext uri="{FF2B5EF4-FFF2-40B4-BE49-F238E27FC236}">
-                <a16:creationId xmlns:a16="http://schemas.microsoft.com/office/drawing/2014/main" id="{80DDFE6A-0805-7B54-8CF2-129C05C534B0}"/>
+                <a16:creationId xmlns:a16="http://schemas.microsoft.com/office/drawing/2014/main" id="{A7B9AF38-26BD-7DDA-7DA6-BE3BAADF2913}"/>
               </a:ext>
             </a:extLst>
           </p:cNvPr>
@@ -3409,7 +3182,7 @@
           <p:nvPr userDrawn="1"/>
         </p:nvPicPr>
         <p:blipFill>
-          <a:blip r:embed="rId13" cstate="print">
+          <a:blip r:embed="rId11" cstate="print">
             <a:extLst>
               <a:ext uri="{28A0092B-C50C-407E-A947-70E740481C1C}">
                 <a14:useLocalDpi xmlns:a14="http://schemas.microsoft.com/office/drawing/2010/main" val="0"/>
@@ -3422,7 +3195,7 @@
         </p:blipFill>
         <p:spPr>
           <a:xfrm>
-            <a:off x="849769" y="2974535"/>
+            <a:off x="732002" y="2974535"/>
             <a:ext cx="1238034" cy="1128739"/>
           </a:xfrm>
           <a:prstGeom prst="rect">
@@ -5110,71 +4883,6 @@
           </a:p>
         </p:txBody>
       </p:sp>
-      <p:sp>
-        <p:nvSpPr>
-          <p:cNvPr id="4" name="Date Placeholder 3"/>
-          <p:cNvSpPr>
-            <a:spLocks noGrp="1"/>
-          </p:cNvSpPr>
-          <p:nvPr>
-            <p:ph type="dt" sz="half" idx="10"/>
-          </p:nvPr>
-        </p:nvSpPr>
-        <p:spPr/>
-        <p:txBody>
-          <a:bodyPr/>
-          <a:lstStyle/>
-          <a:p>
-            <a:fld id="{68F49DD1-DDB5-AB43-B311-7649AD474C82}" type="datetimeFigureOut">
-              <a:rPr lang="en-US" smtClean="0"/>
-              <a:t>1/23/2026</a:t>
-            </a:fld>
-            <a:endParaRPr lang="en-US"/>
-          </a:p>
-        </p:txBody>
-      </p:sp>
-      <p:sp>
-        <p:nvSpPr>
-          <p:cNvPr id="5" name="Footer Placeholder 4"/>
-          <p:cNvSpPr>
-            <a:spLocks noGrp="1"/>
-          </p:cNvSpPr>
-          <p:nvPr>
-            <p:ph type="ftr" sz="quarter" idx="11"/>
-          </p:nvPr>
-        </p:nvSpPr>
-        <p:spPr/>
-        <p:txBody>
-          <a:bodyPr/>
-          <a:lstStyle/>
-          <a:p>
-            <a:endParaRPr lang="en-US"/>
-          </a:p>
-        </p:txBody>
-      </p:sp>
-      <p:sp>
-        <p:nvSpPr>
-          <p:cNvPr id="6" name="Slide Number Placeholder 5"/>
-          <p:cNvSpPr>
-            <a:spLocks noGrp="1"/>
-          </p:cNvSpPr>
-          <p:nvPr>
-            <p:ph type="sldNum" sz="quarter" idx="12"/>
-          </p:nvPr>
-        </p:nvSpPr>
-        <p:spPr/>
-        <p:txBody>
-          <a:bodyPr/>
-          <a:lstStyle/>
-          <a:p>
-            <a:fld id="{AEB3D163-D76A-5F4F-A4CE-5FA8F639A976}" type="slidenum">
-              <a:rPr lang="en-US" smtClean="0"/>
-              <a:t>‹#›</a:t>
-            </a:fld>
-            <a:endParaRPr lang="en-US"/>
-          </a:p>
-        </p:txBody>
-      </p:sp>
     </p:spTree>
     <p:extLst>
       <p:ext uri="{BB962C8B-B14F-4D97-AF65-F5344CB8AC3E}">
@@ -5272,11 +4980,7 @@
           <a:bodyPr/>
           <a:lstStyle/>
           <a:p>
-            <a:fld id="{9CF5EF28-261C-FD41-A360-1A380056DD17}" type="slidenum">
-              <a:rPr lang="en-US" smtClean="0"/>
-              <a:t>‹#›</a:t>
-            </a:fld>
-            <a:endParaRPr lang="en-US"/>
+            <a:endParaRPr lang="en-US" dirty="0"/>
           </a:p>
         </p:txBody>
       </p:sp>
@@ -6165,7 +5869,7 @@
         <p:spPr>
           <a:xfrm>
             <a:off x="3176924" y="2085870"/>
-            <a:ext cx="2034531" cy="424732"/>
+            <a:ext cx="2752677" cy="424732"/>
           </a:xfrm>
         </p:spPr>
         <p:txBody>
@@ -6174,7 +5878,7 @@
           <a:p>
             <a:r>
               <a:rPr lang="en-US" dirty="0"/>
-              <a:t>Anshu Dubey</a:t>
+              <a:t>David E. Bernholdt</a:t>
             </a:r>
           </a:p>
         </p:txBody>
@@ -6197,7 +5901,7 @@
         </p:nvSpPr>
         <p:spPr>
           <a:xfrm>
-            <a:off x="5233071" y="2134517"/>
+            <a:off x="5876253" y="2134517"/>
             <a:ext cx="1690167" cy="376085"/>
           </a:xfrm>
         </p:spPr>
@@ -6207,7 +5911,7 @@
           <a:p>
             <a:r>
               <a:rPr lang="en-US" dirty="0"/>
-              <a:t>(she/her)</a:t>
+              <a:t>(he/him)</a:t>
             </a:r>
           </a:p>
         </p:txBody>
@@ -6235,7 +5939,7 @@
           <a:p>
             <a:r>
               <a:rPr lang="en-US" dirty="0"/>
-              <a:t>Argonne National Laboratory</a:t>
+              <a:t>Oak Ridge National Laboratory</a:t>
             </a:r>
           </a:p>
         </p:txBody>
@@ -6259,7 +5963,7 @@
         <p:spPr>
           <a:xfrm>
             <a:off x="3176925" y="3161813"/>
-            <a:ext cx="8292316" cy="1200329"/>
+            <a:ext cx="8292316" cy="646331"/>
           </a:xfrm>
         </p:spPr>
         <p:txBody>
@@ -6273,29 +5977,8 @@
             </a:pPr>
             <a:r>
               <a:rPr lang="en-US" dirty="0"/>
-              <a:t>Better Software for Science with High-Performance Computing tutorial @ </a:t>
-            </a:r>
-            <a:r>
-              <a:rPr lang="en-US" dirty="0" err="1"/>
-              <a:t>SupercomputingAsia</a:t>
-            </a:r>
-            <a:r>
-              <a:rPr lang="en-US" dirty="0"/>
-              <a:t> 2026 (SCA 2026)/The International Conference on High Performance Computing in Asia-Pacific Region 2026 (</a:t>
-            </a:r>
-            <a:r>
-              <a:rPr lang="en-US" dirty="0" err="1"/>
-              <a:t>HPCAsia</a:t>
-            </a:r>
-            <a:r>
-              <a:rPr lang="en-US" dirty="0"/>
-              <a:t> 2026) conference</a:t>
-            </a:r>
-            <a:endParaRPr lang="en-US" dirty="0">
-              <a:solidFill>
-                <a:srgbClr val="111111"/>
-              </a:solidFill>
-            </a:endParaRPr>
+              <a:t>Software Sustainability track @ Argonne Training Program on Extreme-Scale Computing summer school</a:t>
+            </a:r>
           </a:p>
         </p:txBody>
       </p:sp>
@@ -7225,6 +6908,104 @@
           </a:fontRef>
         </p:style>
       </p:cxnSp>
+      <p:cxnSp>
+        <p:nvCxnSpPr>
+          <p:cNvPr id="6" name="Elbow Connector 5">
+            <a:extLst>
+              <a:ext uri="{FF2B5EF4-FFF2-40B4-BE49-F238E27FC236}">
+                <a16:creationId xmlns:a16="http://schemas.microsoft.com/office/drawing/2014/main" id="{4621E5EC-5C38-F853-C565-BD1A70A75ADF}"/>
+              </a:ext>
+            </a:extLst>
+          </p:cNvPr>
+          <p:cNvCxnSpPr>
+            <a:cxnSpLocks/>
+          </p:cNvCxnSpPr>
+          <p:nvPr/>
+        </p:nvCxnSpPr>
+        <p:spPr>
+          <a:xfrm rot="5400000" flipH="1" flipV="1">
+            <a:off x="5529007" y="3027920"/>
+            <a:ext cx="8638" cy="2696829"/>
+          </a:xfrm>
+          <a:prstGeom prst="bentConnector3">
+            <a:avLst>
+              <a:gd name="adj1" fmla="val 2746446"/>
+            </a:avLst>
+          </a:prstGeom>
+          <a:ln w="38100">
+            <a:solidFill>
+              <a:schemeClr val="bg2">
+                <a:lumMod val="75000"/>
+              </a:schemeClr>
+            </a:solidFill>
+            <a:prstDash val="sysDash"/>
+            <a:tailEnd type="triangle"/>
+          </a:ln>
+        </p:spPr>
+        <p:style>
+          <a:lnRef idx="1">
+            <a:schemeClr val="accent1"/>
+          </a:lnRef>
+          <a:fillRef idx="0">
+            <a:schemeClr val="accent1"/>
+          </a:fillRef>
+          <a:effectRef idx="0">
+            <a:schemeClr val="accent1"/>
+          </a:effectRef>
+          <a:fontRef idx="minor">
+            <a:schemeClr val="tx1"/>
+          </a:fontRef>
+        </p:style>
+      </p:cxnSp>
+      <p:cxnSp>
+        <p:nvCxnSpPr>
+          <p:cNvPr id="7" name="Elbow Connector 12">
+            <a:extLst>
+              <a:ext uri="{FF2B5EF4-FFF2-40B4-BE49-F238E27FC236}">
+                <a16:creationId xmlns:a16="http://schemas.microsoft.com/office/drawing/2014/main" id="{51348BFD-08C3-B156-EFD7-6B7A99C2E361}"/>
+              </a:ext>
+            </a:extLst>
+          </p:cNvPr>
+          <p:cNvCxnSpPr>
+            <a:cxnSpLocks/>
+          </p:cNvCxnSpPr>
+          <p:nvPr/>
+        </p:nvCxnSpPr>
+        <p:spPr>
+          <a:xfrm rot="5400000" flipH="1" flipV="1">
+            <a:off x="5532449" y="1036290"/>
+            <a:ext cx="1" cy="2695078"/>
+          </a:xfrm>
+          <a:prstGeom prst="bentConnector3">
+            <a:avLst>
+              <a:gd name="adj1" fmla="val -22860000000"/>
+            </a:avLst>
+          </a:prstGeom>
+          <a:ln w="38100">
+            <a:solidFill>
+              <a:schemeClr val="bg2">
+                <a:lumMod val="75000"/>
+              </a:schemeClr>
+            </a:solidFill>
+            <a:prstDash val="sysDash"/>
+            <a:tailEnd type="triangle"/>
+          </a:ln>
+        </p:spPr>
+        <p:style>
+          <a:lnRef idx="1">
+            <a:schemeClr val="accent1"/>
+          </a:lnRef>
+          <a:fillRef idx="0">
+            <a:schemeClr val="accent1"/>
+          </a:fillRef>
+          <a:effectRef idx="0">
+            <a:schemeClr val="accent1"/>
+          </a:effectRef>
+          <a:fontRef idx="minor">
+            <a:schemeClr val="tx1"/>
+          </a:fontRef>
+        </p:style>
+      </p:cxnSp>
     </p:spTree>
     <p:extLst>
       <p:ext uri="{BB962C8B-B14F-4D97-AF65-F5344CB8AC3E}">
@@ -7239,7 +7020,7 @@
 </file>
 
 <file path=ppt/slides/slide11.xml><?xml version="1.0" encoding="utf-8"?>
-<p:sld xmlns:a="http://schemas.openxmlformats.org/drawingml/2006/main" xmlns:r="http://schemas.openxmlformats.org/officeDocument/2006/relationships" xmlns:p="http://schemas.openxmlformats.org/presentationml/2006/main">
+<p:sld xmlns:a="http://schemas.openxmlformats.org/drawingml/2006/main" xmlns:r="http://schemas.openxmlformats.org/officeDocument/2006/relationships" xmlns:p="http://schemas.openxmlformats.org/presentationml/2006/main" show="0">
   <p:cSld>
     <p:spTree>
       <p:nvGrpSpPr>
@@ -10002,7 +9783,7 @@
           <a:noFill/>
           <a:extLst>
             <a:ext uri="{909E8E84-426E-40dd-AFC4-6F175D3DCCD1}">
-              <a14:hiddenFill xmlns:a14="http://schemas.microsoft.com/office/drawing/2010/main" xmlns="">
+              <a14:hiddenFill xmlns="" xmlns:a14="http://schemas.microsoft.com/office/drawing/2010/main">
                 <a:solidFill>
                   <a:srgbClr val="FFFFFF"/>
                 </a:solidFill>
@@ -15347,29 +15128,13 @@
             </a:r>
             <a:r>
               <a:rPr lang="en-US" sz="1600" dirty="0"/>
-              <a:t>Anshu Dubey and Akash Dhruv, Better Software for Science with High-Performance Computing tutorial, in </a:t>
-            </a:r>
-            <a:r>
-              <a:rPr lang="en-US" sz="1600" dirty="0" err="1"/>
-              <a:t>SupercomputingAsia</a:t>
-            </a:r>
-            <a:r>
-              <a:rPr lang="en-US" sz="1600" dirty="0"/>
-              <a:t> 2026 (SCA 2026)/The International Conference on High Performance Computing in Asia-Pacific Region 2026 (</a:t>
-            </a:r>
-            <a:r>
-              <a:rPr lang="en-US" sz="1600" dirty="0" err="1"/>
-              <a:t>HPCAsia</a:t>
-            </a:r>
-            <a:r>
-              <a:rPr lang="en-US" sz="1600" dirty="0"/>
-              <a:t> 2026), Osaka, Japan, 2026. DOI: </a:t>
+              <a:t>David E. Bernholdt, Software Sustainability track, in Argonne Training Program on Extreme-Scale Computing, St. Charles, Illinois, 2026. DOI: </a:t>
             </a:r>
             <a:r>
               <a:rPr lang="en-US" sz="1600" dirty="0">
                 <a:hlinkClick r:id="rId4"/>
               </a:rPr>
-              <a:t>10.6084/m9.figshare.31130062</a:t>
+              <a:t>10.6084/m9.figshare.33139910</a:t>
             </a:r>
             <a:r>
               <a:rPr lang="en-US" sz="1600" dirty="0"/>
@@ -15569,7 +15334,7 @@
     </p:spTree>
     <p:extLst>
       <p:ext uri="{BB962C8B-B14F-4D97-AF65-F5344CB8AC3E}">
-        <p14:creationId xmlns:p14="http://schemas.microsoft.com/office/powerpoint/2010/main" val="978726433"/>
+        <p14:creationId xmlns:p14="http://schemas.microsoft.com/office/powerpoint/2010/main" val="1132758061"/>
       </p:ext>
     </p:extLst>
   </p:cSld>
@@ -20951,55 +20716,6 @@
       </p:sp>
       <p:sp>
         <p:nvSpPr>
-          <p:cNvPr id="6" name="Rectangle 5">
-            <a:extLst>
-              <a:ext uri="{FF2B5EF4-FFF2-40B4-BE49-F238E27FC236}">
-                <a16:creationId xmlns:a16="http://schemas.microsoft.com/office/drawing/2014/main" id="{A28BA85B-9464-EA29-2DC2-27EDB4AE3F06}"/>
-              </a:ext>
-            </a:extLst>
-          </p:cNvPr>
-          <p:cNvSpPr/>
-          <p:nvPr/>
-        </p:nvSpPr>
-        <p:spPr>
-          <a:xfrm>
-            <a:off x="3612970" y="5802774"/>
-            <a:ext cx="3997935" cy="438797"/>
-          </a:xfrm>
-          <a:prstGeom prst="rect">
-            <a:avLst/>
-          </a:prstGeom>
-        </p:spPr>
-        <p:style>
-          <a:lnRef idx="2">
-            <a:schemeClr val="accent1">
-              <a:shade val="15000"/>
-            </a:schemeClr>
-          </a:lnRef>
-          <a:fillRef idx="1">
-            <a:schemeClr val="accent1"/>
-          </a:fillRef>
-          <a:effectRef idx="0">
-            <a:schemeClr val="accent1"/>
-          </a:effectRef>
-          <a:fontRef idx="minor">
-            <a:schemeClr val="lt1"/>
-          </a:fontRef>
-        </p:style>
-        <p:txBody>
-          <a:bodyPr rtlCol="0" anchor="ctr"/>
-          <a:lstStyle/>
-          <a:p>
-            <a:pPr algn="ctr"/>
-            <a:r>
-              <a:rPr lang="en-US" dirty="0"/>
-              <a:t>Is there another way?</a:t>
-            </a:r>
-          </a:p>
-        </p:txBody>
-      </p:sp>
-      <p:sp>
-        <p:nvSpPr>
           <p:cNvPr id="7" name="Rectangle 6">
             <a:extLst>
               <a:ext uri="{FF2B5EF4-FFF2-40B4-BE49-F238E27FC236}">
@@ -21061,7 +20777,7 @@
 </file>
 
 <file path=ppt/slides/slide27.xml><?xml version="1.0" encoding="utf-8"?>
-<p:sld xmlns:a="http://schemas.openxmlformats.org/drawingml/2006/main" xmlns:r="http://schemas.openxmlformats.org/officeDocument/2006/relationships" xmlns:p="http://schemas.openxmlformats.org/presentationml/2006/main">
+<p:sld xmlns:a="http://schemas.openxmlformats.org/drawingml/2006/main" xmlns:r="http://schemas.openxmlformats.org/officeDocument/2006/relationships" xmlns:p="http://schemas.openxmlformats.org/presentationml/2006/main" show="0">
   <p:cSld>
     <p:spTree>
       <p:nvGrpSpPr>
@@ -21407,7 +21123,7 @@
 </file>
 
 <file path=ppt/slides/slide28.xml><?xml version="1.0" encoding="utf-8"?>
-<p:sld xmlns:a="http://schemas.openxmlformats.org/drawingml/2006/main" xmlns:r="http://schemas.openxmlformats.org/officeDocument/2006/relationships" xmlns:p="http://schemas.openxmlformats.org/presentationml/2006/main">
+<p:sld xmlns:a="http://schemas.openxmlformats.org/drawingml/2006/main" xmlns:r="http://schemas.openxmlformats.org/officeDocument/2006/relationships" xmlns:p="http://schemas.openxmlformats.org/presentationml/2006/main" show="0">
   <p:cSld>
     <p:spTree>
       <p:nvGrpSpPr>
@@ -21898,13 +21614,13 @@
   <p:clrMapOvr>
     <a:masterClrMapping/>
   </p:clrMapOvr>
-  <mc:AlternateContent xmlns:mc="http://schemas.openxmlformats.org/markup-compatibility/2006" xmlns:p14="http://schemas.microsoft.com/office/powerpoint/2010/main">
-    <mc:Choice Requires="p14">
+  <mc:AlternateContent xmlns:mc="http://schemas.openxmlformats.org/markup-compatibility/2006">
+    <mc:Choice xmlns:p14="http://schemas.microsoft.com/office/powerpoint/2010/main" Requires="p14">
       <p:transition p14:dur="250">
         <p:fade/>
       </p:transition>
     </mc:Choice>
-    <mc:Fallback xmlns="">
+    <mc:Fallback>
       <p:transition>
         <p:fade/>
       </p:transition>
@@ -21914,7 +21630,7 @@
 </file>
 
 <file path=ppt/slides/slide29.xml><?xml version="1.0" encoding="utf-8"?>
-<p:sld xmlns:a="http://schemas.openxmlformats.org/drawingml/2006/main" xmlns:r="http://schemas.openxmlformats.org/officeDocument/2006/relationships" xmlns:p="http://schemas.openxmlformats.org/presentationml/2006/main">
+<p:sld xmlns:a="http://schemas.openxmlformats.org/drawingml/2006/main" xmlns:r="http://schemas.openxmlformats.org/officeDocument/2006/relationships" xmlns:p="http://schemas.openxmlformats.org/presentationml/2006/main" show="0">
   <p:cSld>
     <p:spTree>
       <p:nvGrpSpPr>
@@ -23000,7 +22716,7 @@
 </file>
 
 <file path=ppt/slides/slide30.xml><?xml version="1.0" encoding="utf-8"?>
-<p:sld xmlns:a="http://schemas.openxmlformats.org/drawingml/2006/main" xmlns:r="http://schemas.openxmlformats.org/officeDocument/2006/relationships" xmlns:p="http://schemas.openxmlformats.org/presentationml/2006/main">
+<p:sld xmlns:a="http://schemas.openxmlformats.org/drawingml/2006/main" xmlns:r="http://schemas.openxmlformats.org/officeDocument/2006/relationships" xmlns:p="http://schemas.openxmlformats.org/presentationml/2006/main" show="0">
   <p:cSld>
     <p:spTree>
       <p:nvGrpSpPr>
@@ -23187,7 +22903,7 @@
 </file>
 
 <file path=ppt/slides/slide31.xml><?xml version="1.0" encoding="utf-8"?>
-<p:sld xmlns:a="http://schemas.openxmlformats.org/drawingml/2006/main" xmlns:r="http://schemas.openxmlformats.org/officeDocument/2006/relationships" xmlns:p="http://schemas.openxmlformats.org/presentationml/2006/main">
+<p:sld xmlns:a="http://schemas.openxmlformats.org/drawingml/2006/main" xmlns:r="http://schemas.openxmlformats.org/officeDocument/2006/relationships" xmlns:p="http://schemas.openxmlformats.org/presentationml/2006/main" show="0">
   <p:cSld>
     <p:spTree>
       <p:nvGrpSpPr>
@@ -24532,13 +24248,13 @@
   <p:clrMapOvr>
     <a:masterClrMapping/>
   </p:clrMapOvr>
-  <mc:AlternateContent xmlns:mc="http://schemas.openxmlformats.org/markup-compatibility/2006" xmlns:p14="http://schemas.microsoft.com/office/powerpoint/2010/main">
-    <mc:Choice Requires="p14">
+  <mc:AlternateContent xmlns:mc="http://schemas.openxmlformats.org/markup-compatibility/2006">
+    <mc:Choice xmlns:p14="http://schemas.microsoft.com/office/powerpoint/2010/main" Requires="p14">
       <p:transition p14:dur="250">
         <p:fade/>
       </p:transition>
     </mc:Choice>
-    <mc:Fallback xmlns="">
+    <mc:Fallback>
       <p:transition>
         <p:fade/>
       </p:transition>
@@ -24548,7 +24264,7 @@
 </file>
 
 <file path=ppt/slides/slide32.xml><?xml version="1.0" encoding="utf-8"?>
-<p:sld xmlns:a="http://schemas.openxmlformats.org/drawingml/2006/main" xmlns:r="http://schemas.openxmlformats.org/officeDocument/2006/relationships" xmlns:p="http://schemas.openxmlformats.org/presentationml/2006/main">
+<p:sld xmlns:a="http://schemas.openxmlformats.org/drawingml/2006/main" xmlns:r="http://schemas.openxmlformats.org/officeDocument/2006/relationships" xmlns:p="http://schemas.openxmlformats.org/presentationml/2006/main" show="0">
   <p:cSld>
     <p:spTree>
       <p:nvGrpSpPr>
@@ -25785,13 +25501,13 @@
   <p:clrMapOvr>
     <a:masterClrMapping/>
   </p:clrMapOvr>
-  <mc:AlternateContent xmlns:mc="http://schemas.openxmlformats.org/markup-compatibility/2006" xmlns:p14="http://schemas.microsoft.com/office/powerpoint/2010/main">
-    <mc:Choice Requires="p14">
+  <mc:AlternateContent xmlns:mc="http://schemas.openxmlformats.org/markup-compatibility/2006">
+    <mc:Choice xmlns:p14="http://schemas.microsoft.com/office/powerpoint/2010/main" Requires="p14">
       <p:transition p14:dur="250">
         <p:fade/>
       </p:transition>
     </mc:Choice>
-    <mc:Fallback xmlns="">
+    <mc:Fallback>
       <p:transition>
         <p:fade/>
       </p:transition>
@@ -25801,7 +25517,7 @@
 </file>
 
 <file path=ppt/slides/slide33.xml><?xml version="1.0" encoding="utf-8"?>
-<p:sld xmlns:a="http://schemas.openxmlformats.org/drawingml/2006/main" xmlns:r="http://schemas.openxmlformats.org/officeDocument/2006/relationships" xmlns:p="http://schemas.openxmlformats.org/presentationml/2006/main">
+<p:sld xmlns:a="http://schemas.openxmlformats.org/drawingml/2006/main" xmlns:r="http://schemas.openxmlformats.org/officeDocument/2006/relationships" xmlns:p="http://schemas.openxmlformats.org/presentationml/2006/main" show="0">
   <p:cSld>
     <p:spTree>
       <p:nvGrpSpPr>
@@ -27348,13 +27064,13 @@
   <p:clrMapOvr>
     <a:masterClrMapping/>
   </p:clrMapOvr>
-  <mc:AlternateContent xmlns:mc="http://schemas.openxmlformats.org/markup-compatibility/2006" xmlns:p14="http://schemas.microsoft.com/office/powerpoint/2010/main">
-    <mc:Choice Requires="p14">
+  <mc:AlternateContent xmlns:mc="http://schemas.openxmlformats.org/markup-compatibility/2006">
+    <mc:Choice xmlns:p14="http://schemas.microsoft.com/office/powerpoint/2010/main" Requires="p14">
       <p:transition p14:dur="250">
         <p:fade/>
       </p:transition>
     </mc:Choice>
-    <mc:Fallback xmlns="">
+    <mc:Fallback>
       <p:transition>
         <p:fade/>
       </p:transition>
@@ -27364,7 +27080,7 @@
 </file>
 
 <file path=ppt/slides/slide34.xml><?xml version="1.0" encoding="utf-8"?>
-<p:sld xmlns:a="http://schemas.openxmlformats.org/drawingml/2006/main" xmlns:r="http://schemas.openxmlformats.org/officeDocument/2006/relationships" xmlns:p="http://schemas.openxmlformats.org/presentationml/2006/main">
+<p:sld xmlns:a="http://schemas.openxmlformats.org/drawingml/2006/main" xmlns:r="http://schemas.openxmlformats.org/officeDocument/2006/relationships" xmlns:p="http://schemas.openxmlformats.org/presentationml/2006/main" show="0">
   <p:cSld>
     <p:spTree>
       <p:nvGrpSpPr>
@@ -29179,13 +28895,13 @@
   <p:clrMapOvr>
     <a:masterClrMapping/>
   </p:clrMapOvr>
-  <mc:AlternateContent xmlns:mc="http://schemas.openxmlformats.org/markup-compatibility/2006" xmlns:p14="http://schemas.microsoft.com/office/powerpoint/2010/main">
-    <mc:Choice Requires="p14">
+  <mc:AlternateContent xmlns:mc="http://schemas.openxmlformats.org/markup-compatibility/2006">
+    <mc:Choice xmlns:p14="http://schemas.microsoft.com/office/powerpoint/2010/main" Requires="p14">
       <p:transition p14:dur="250">
         <p:fade/>
       </p:transition>
     </mc:Choice>
-    <mc:Fallback xmlns="">
+    <mc:Fallback>
       <p:transition>
         <p:fade/>
       </p:transition>
@@ -31301,6 +31017,13 @@
             <a:r>
               <a:rPr lang="en-US" dirty="0"/>
               <a:t>Components for verification</a:t>
+            </a:r>
+          </a:p>
+          <a:p>
+            <a:pPr lvl="1"/>
+            <a:r>
+              <a:rPr lang="en-US" dirty="0"/>
+              <a:t>Tests</a:t>
             </a:r>
           </a:p>
           <a:p>
@@ -34325,21 +34048,6 @@
 </file>
 
 <file path=customXml/item1.xml><?xml version="1.0" encoding="utf-8"?>
-<?mso-contentType ?>
-<FormTemplates xmlns="http://schemas.microsoft.com/sharepoint/v3/contenttype/forms">
-  <Display>DocumentLibraryForm</Display>
-  <Edit>DocumentLibraryForm</Edit>
-  <New>DocumentLibraryForm</New>
-</FormTemplates>
-</file>
-
-<file path=customXml/item2.xml><?xml version="1.0" encoding="utf-8"?>
-<p:properties xmlns:p="http://schemas.microsoft.com/office/2006/metadata/properties" xmlns:xsi="http://www.w3.org/2001/XMLSchema-instance" xmlns:pc="http://schemas.microsoft.com/office/infopath/2007/PartnerControls">
-  <documentManagement/>
-</p:properties>
-</file>
-
-<file path=customXml/item3.xml><?xml version="1.0" encoding="utf-8"?>
 <ct:contentTypeSchema xmlns:ct="http://schemas.microsoft.com/office/2006/metadata/contentType" xmlns:ma="http://schemas.microsoft.com/office/2006/metadata/properties/metaAttributes" ct:_="" ma:_="" ma:contentTypeName="Document" ma:contentTypeID="0x010100565464437F680748A68B85EB6594EA7D" ma:contentTypeVersion="0" ma:contentTypeDescription="Create a new document." ma:contentTypeScope="" ma:versionID="fe3f4dd58d5914c51cfc6deaa8ad845c">
   <xsd:schema xmlns:xsd="http://www.w3.org/2001/XMLSchema" xmlns:p="http://schemas.microsoft.com/office/2006/metadata/properties" targetNamespace="http://schemas.microsoft.com/office/2006/metadata/properties" ma:root="true" ma:fieldsID="4aeb20c0e3442673af7ee10786458764">
     <xsd:element name="properties">
@@ -34388,10 +34096,32 @@
 </ct:contentTypeSchema>
 </file>
 
+<file path=customXml/item2.xml><?xml version="1.0" encoding="utf-8"?>
+<p:properties xmlns:p="http://schemas.microsoft.com/office/2006/metadata/properties" xmlns:xsi="http://www.w3.org/2001/XMLSchema-instance" xmlns:pc="http://schemas.microsoft.com/office/infopath/2007/PartnerControls">
+  <documentManagement/>
+</p:properties>
+</file>
+
+<file path=customXml/item3.xml><?xml version="1.0" encoding="utf-8"?>
+<?mso-contentType ?>
+<FormTemplates xmlns="http://schemas.microsoft.com/sharepoint/v3/contenttype/forms">
+  <Display>DocumentLibraryForm</Display>
+  <Edit>DocumentLibraryForm</Edit>
+  <New>DocumentLibraryForm</New>
+</FormTemplates>
+</file>
+
 <file path=customXml/itemProps1.xml><?xml version="1.0" encoding="utf-8"?>
-<ds:datastoreItem xmlns:ds="http://schemas.openxmlformats.org/officeDocument/2006/customXml" ds:itemID="{19E20559-B232-4371-8690-E3D8007EDB82}">
+<ds:datastoreItem xmlns:ds="http://schemas.openxmlformats.org/officeDocument/2006/customXml" ds:itemID="{E8DB7DEB-074E-4EE8-9B6E-FD277323109C}">
   <ds:schemaRefs>
-    <ds:schemaRef ds:uri="http://schemas.microsoft.com/sharepoint/v3/contenttype/forms"/>
+    <ds:schemaRef ds:uri="http://schemas.microsoft.com/office/2006/metadata/contentType"/>
+    <ds:schemaRef ds:uri="http://schemas.microsoft.com/office/2006/metadata/properties/metaAttributes"/>
+    <ds:schemaRef ds:uri="http://www.w3.org/2001/XMLSchema"/>
+    <ds:schemaRef ds:uri="http://schemas.microsoft.com/office/2006/metadata/properties"/>
+    <ds:schemaRef ds:uri="http://schemas.openxmlformats.org/package/2006/metadata/core-properties"/>
+    <ds:schemaRef ds:uri="http://purl.org/dc/elements/1.1/"/>
+    <ds:schemaRef ds:uri="http://purl.org/dc/terms/"/>
+    <ds:schemaRef ds:uri="http://schemas.microsoft.com/office/internal/2005/internalDocumentation"/>
   </ds:schemaRefs>
 </ds:datastoreItem>
 </file>
@@ -34412,16 +34142,9 @@
 </file>
 
 <file path=customXml/itemProps3.xml><?xml version="1.0" encoding="utf-8"?>
-<ds:datastoreItem xmlns:ds="http://schemas.openxmlformats.org/officeDocument/2006/customXml" ds:itemID="{E8DB7DEB-074E-4EE8-9B6E-FD277323109C}">
+<ds:datastoreItem xmlns:ds="http://schemas.openxmlformats.org/officeDocument/2006/customXml" ds:itemID="{19E20559-B232-4371-8690-E3D8007EDB82}">
   <ds:schemaRefs>
-    <ds:schemaRef ds:uri="http://schemas.microsoft.com/office/2006/metadata/contentType"/>
-    <ds:schemaRef ds:uri="http://schemas.microsoft.com/office/2006/metadata/properties/metaAttributes"/>
-    <ds:schemaRef ds:uri="http://www.w3.org/2001/XMLSchema"/>
-    <ds:schemaRef ds:uri="http://schemas.microsoft.com/office/2006/metadata/properties"/>
-    <ds:schemaRef ds:uri="http://schemas.openxmlformats.org/package/2006/metadata/core-properties"/>
-    <ds:schemaRef ds:uri="http://purl.org/dc/elements/1.1/"/>
-    <ds:schemaRef ds:uri="http://purl.org/dc/terms/"/>
-    <ds:schemaRef ds:uri="http://schemas.microsoft.com/office/internal/2005/internalDocumentation"/>
+    <ds:schemaRef ds:uri="http://schemas.microsoft.com/sharepoint/v3/contenttype/forms"/>
   </ds:schemaRefs>
 </ds:datastoreItem>
 </file>
</xml_diff>